<commit_message>
[KOEA-10989] ch05-slides revision — fix G0 blockers (bullet count + truncation)
- scripts/build-ch05-slides.py: new curated-content generator for ch05
  production-agents-claude-agent-sdk-mcp-connector; 7 slides, all prose bullets
- All hook slides (slides 3-6) now have 5 prose bullets: what hook returns,
  when to use / when NOT to use, production gotcha or footgun
- No 140-char truncation — all 25 bullets manually curated at 88-110 chars
- No code-line text boxes; ch05-slides.pptx regenerated from this script

Co-Authored-By: Claude Sonnet 4.6 <noreply@anthropic.com>
</commit_message>
<xml_diff>
--- a/vault/courses/production-agents-claude-agent-sdk-mcp-connector/ch05-slides.pptx
+++ b/vault/courses/production-agents-claude-agent-sdk-mcp-connector/ch05-slides.pptx
@@ -3087,14 +3087,6 @@
 <file path=ppt/slides/slide1.xml><?xml version="1.0" encoding="utf-8"?>
 <p:sld xmlns:a="http://schemas.openxmlformats.org/drawingml/2006/main" xmlns:p="http://schemas.openxmlformats.org/presentationml/2006/main" xmlns:r="http://schemas.openxmlformats.org/officeDocument/2006/relationships">
   <p:cSld>
-    <p:bg>
-      <p:bgPr>
-        <a:solidFill>
-          <a:srgbClr val="18181B"/>
-        </a:solidFill>
-        <a:effectLst/>
-      </p:bgPr>
-    </p:bg>
     <p:spTree>
       <p:nvGrpSpPr>
         <p:cNvPr id="1" name=""/>
@@ -3104,148 +3096,20 @@
       <p:grpSpPr/>
       <p:sp>
         <p:nvSpPr>
-          <p:cNvPr id="2" name="TextBox 1"/>
-          <p:cNvSpPr txBox="1"/>
-          <p:nvPr/>
-        </p:nvSpPr>
-        <p:spPr>
-          <a:xfrm>
-            <a:off x="914400" y="1828800"/>
-            <a:ext cx="10332720" cy="2286000"/>
-          </a:xfrm>
-          <a:prstGeom prst="rect">
-            <a:avLst/>
-          </a:prstGeom>
-          <a:noFill/>
-        </p:spPr>
-        <p:txBody>
-          <a:bodyPr wrap="square">
-            <a:spAutoFit/>
-          </a:bodyPr>
-          <a:lstStyle/>
-          <a:p>
-            <a:pPr algn="ctr"/>
-            <a:r>
-              <a:rPr sz="3400" b="1">
-                <a:solidFill>
-                  <a:srgbClr val="FFFFFF"/>
-                </a:solidFill>
-              </a:rPr>
-              <a:t>Production: deploy + observability + cost controls</a:t>
-            </a:r>
-          </a:p>
-        </p:txBody>
-      </p:sp>
-      <p:sp>
-        <p:nvSpPr>
-          <p:cNvPr id="3" name="TextBox 2"/>
-          <p:cNvSpPr txBox="1"/>
-          <p:nvPr/>
-        </p:nvSpPr>
-        <p:spPr>
-          <a:xfrm>
-            <a:off x="731520" y="6263640"/>
-            <a:ext cx="10698480" cy="365760"/>
-          </a:xfrm>
-          <a:prstGeom prst="rect">
-            <a:avLst/>
-          </a:prstGeom>
-          <a:noFill/>
-        </p:spPr>
-        <p:txBody>
-          <a:bodyPr wrap="square">
-            <a:spAutoFit/>
-          </a:bodyPr>
-          <a:lstStyle/>
-          <a:p>
-            <a:pPr algn="l"/>
-            <a:r>
-              <a:rPr sz="1000" b="0">
-                <a:solidFill>
-                  <a:srgbClr val="A1A1AA"/>
-                </a:solidFill>
-              </a:rPr>
-              <a:t>academy.kspl.tech | Koenig AI Academy</a:t>
-            </a:r>
-          </a:p>
-        </p:txBody>
-      </p:sp>
-    </p:spTree>
-  </p:cSld>
-  <p:clrMapOvr>
-    <a:masterClrMapping/>
-  </p:clrMapOvr>
-</p:sld>
-</file>
-
-<file path=ppt/slides/slide2.xml><?xml version="1.0" encoding="utf-8"?>
-<p:sld xmlns:a="http://schemas.openxmlformats.org/drawingml/2006/main" xmlns:p="http://schemas.openxmlformats.org/presentationml/2006/main" xmlns:r="http://schemas.openxmlformats.org/officeDocument/2006/relationships">
-  <p:cSld>
-    <p:bg>
-      <p:bgPr>
-        <a:solidFill>
-          <a:srgbClr val="18181B"/>
-        </a:solidFill>
-        <a:effectLst/>
-      </p:bgPr>
-    </p:bg>
-    <p:spTree>
-      <p:nvGrpSpPr>
-        <p:cNvPr id="1" name=""/>
-        <p:cNvGrpSpPr/>
-        <p:nvPr/>
-      </p:nvGrpSpPr>
-      <p:grpSpPr/>
-      <p:sp>
-        <p:nvSpPr>
-          <p:cNvPr id="2" name="TextBox 1"/>
-          <p:cNvSpPr txBox="1"/>
-          <p:nvPr/>
-        </p:nvSpPr>
-        <p:spPr>
-          <a:xfrm>
-            <a:off x="731520" y="411480"/>
-            <a:ext cx="10698480" cy="1005840"/>
-          </a:xfrm>
-          <a:prstGeom prst="rect">
-            <a:avLst/>
-          </a:prstGeom>
-          <a:noFill/>
-        </p:spPr>
-        <p:txBody>
-          <a:bodyPr wrap="square">
-            <a:spAutoFit/>
-          </a:bodyPr>
-          <a:lstStyle/>
-          <a:p>
-            <a:pPr algn="l"/>
-            <a:r>
-              <a:rPr sz="2800" b="1">
-                <a:solidFill>
-                  <a:srgbClr val="FFFFFF"/>
-                </a:solidFill>
-              </a:rPr>
-              <a:t>Key facts</a:t>
-            </a:r>
-          </a:p>
-        </p:txBody>
-      </p:sp>
-      <p:sp>
-        <p:nvSpPr>
-          <p:cNvPr id="3" name="Rectangle 2"/>
+          <p:cNvPr id="2" name="Rectangle 1"/>
           <p:cNvSpPr/>
           <p:nvPr/>
         </p:nvSpPr>
         <p:spPr>
           <a:xfrm>
-            <a:off x="731520" y="1417320"/>
-            <a:ext cx="10698480" cy="36576"/>
+            <a:off x="0" y="0"/>
+            <a:ext cx="12191695" cy="6858000"/>
           </a:xfrm>
           <a:prstGeom prst="rect">
             <a:avLst/>
           </a:prstGeom>
           <a:solidFill>
-            <a:srgbClr val="A1A1AA"/>
+            <a:srgbClr val="18181B"/>
           </a:solidFill>
           <a:ln>
             <a:noFill/>
@@ -3275,250 +3139,20 @@
       </p:sp>
       <p:sp>
         <p:nvSpPr>
-          <p:cNvPr id="4" name="TextBox 3"/>
-          <p:cNvSpPr txBox="1"/>
-          <p:nvPr/>
-        </p:nvSpPr>
-        <p:spPr>
-          <a:xfrm>
-            <a:off x="731520" y="1600200"/>
-            <a:ext cx="10698480" cy="960120"/>
-          </a:xfrm>
-          <a:prstGeom prst="rect">
-            <a:avLst/>
-          </a:prstGeom>
-          <a:noFill/>
-        </p:spPr>
-        <p:txBody>
-          <a:bodyPr wrap="square">
-            <a:spAutoFit/>
-          </a:bodyPr>
-          <a:lstStyle/>
-          <a:p>
-            <a:pPr algn="l"/>
-            <a:r>
-              <a:rPr sz="1700" b="0">
-                <a:solidFill>
-                  <a:srgbClr val="FFFFFF"/>
-                </a:solidFill>
-              </a:rPr>
-              <a:t>  The Agent SDK supports seven hook event types: PreToolUse, PostToolUse, Stop, SessionStart, SessionEnd, UserPromptSubmit, and additional eve</a:t>
-            </a:r>
-          </a:p>
-        </p:txBody>
-      </p:sp>
-      <p:sp>
-        <p:nvSpPr>
-          <p:cNvPr id="5" name="TextBox 4"/>
-          <p:cNvSpPr txBox="1"/>
-          <p:nvPr/>
-        </p:nvSpPr>
-        <p:spPr>
-          <a:xfrm>
-            <a:off x="731520" y="2651760"/>
-            <a:ext cx="10698480" cy="960120"/>
-          </a:xfrm>
-          <a:prstGeom prst="rect">
-            <a:avLst/>
-          </a:prstGeom>
-          <a:noFill/>
-        </p:spPr>
-        <p:txBody>
-          <a:bodyPr wrap="square">
-            <a:spAutoFit/>
-          </a:bodyPr>
-          <a:lstStyle/>
-          <a:p>
-            <a:pPr algn="l"/>
-            <a:r>
-              <a:rPr sz="1700" b="0">
-                <a:solidFill>
-                  <a:srgbClr val="FFFFFF"/>
-                </a:solidFill>
-              </a:rPr>
-              <a:t>  permissionMode: "bypassPermissions" disables ALL safety checks, including file-edit confirmations and destructive Bash command prompts — not</a:t>
-            </a:r>
-          </a:p>
-        </p:txBody>
-      </p:sp>
-      <p:sp>
-        <p:nvSpPr>
-          <p:cNvPr id="6" name="TextBox 5"/>
-          <p:cNvSpPr txBox="1"/>
-          <p:nvPr/>
-        </p:nvSpPr>
-        <p:spPr>
-          <a:xfrm>
-            <a:off x="731520" y="3703320"/>
-            <a:ext cx="10698480" cy="960120"/>
-          </a:xfrm>
-          <a:prstGeom prst="rect">
-            <a:avLst/>
-          </a:prstGeom>
-          <a:noFill/>
-        </p:spPr>
-        <p:txBody>
-          <a:bodyPr wrap="square">
-            <a:spAutoFit/>
-          </a:bodyPr>
-          <a:lstStyle/>
-          <a:p>
-            <a:pPr algn="l"/>
-            <a:r>
-              <a:rPr sz="1700" b="0">
-                <a:solidFill>
-                  <a:srgbClr val="FFFFFF"/>
-                </a:solidFill>
-              </a:rPr>
-              <a:t>  Session JSONL files are written to ~/.claude/sessions/ by default and can be redirected with the CLAUDE_SESSIONS_DIR environment variable [1</a:t>
-            </a:r>
-          </a:p>
-        </p:txBody>
-      </p:sp>
-      <p:sp>
-        <p:nvSpPr>
-          <p:cNvPr id="7" name="TextBox 6"/>
-          <p:cNvSpPr txBox="1"/>
-          <p:nvPr/>
-        </p:nvSpPr>
-        <p:spPr>
-          <a:xfrm>
-            <a:off x="731520" y="4754880"/>
-            <a:ext cx="10698480" cy="960120"/>
-          </a:xfrm>
-          <a:prstGeom prst="rect">
-            <a:avLst/>
-          </a:prstGeom>
-          <a:noFill/>
-        </p:spPr>
-        <p:txBody>
-          <a:bodyPr wrap="square">
-            <a:spAutoFit/>
-          </a:bodyPr>
-          <a:lstStyle/>
-          <a:p>
-            <a:pPr algn="l"/>
-            <a:r>
-              <a:rPr sz="1700" b="0">
-                <a:solidFill>
-                  <a:srgbClr val="FFFFFF"/>
-                </a:solidFill>
-              </a:rPr>
-              <a:t>  Setting sources load in order: global (~/.claude/), then project (.claude/), then inline options. Inline options override everything [1].</a:t>
-            </a:r>
-          </a:p>
-        </p:txBody>
-      </p:sp>
-      <p:sp>
-        <p:nvSpPr>
-          <p:cNvPr id="8" name="TextBox 7"/>
-          <p:cNvSpPr txBox="1"/>
-          <p:nvPr/>
-        </p:nvSpPr>
-        <p:spPr>
-          <a:xfrm>
-            <a:off x="731520" y="6263640"/>
-            <a:ext cx="10698480" cy="365760"/>
-          </a:xfrm>
-          <a:prstGeom prst="rect">
-            <a:avLst/>
-          </a:prstGeom>
-          <a:noFill/>
-        </p:spPr>
-        <p:txBody>
-          <a:bodyPr wrap="square">
-            <a:spAutoFit/>
-          </a:bodyPr>
-          <a:lstStyle/>
-          <a:p>
-            <a:pPr algn="l"/>
-            <a:r>
-              <a:rPr sz="1000" b="0">
-                <a:solidFill>
-                  <a:srgbClr val="A1A1AA"/>
-                </a:solidFill>
-              </a:rPr>
-              <a:t>academy.kspl.tech | Koenig AI Academy</a:t>
-            </a:r>
-          </a:p>
-        </p:txBody>
-      </p:sp>
-    </p:spTree>
-  </p:cSld>
-  <p:clrMapOvr>
-    <a:masterClrMapping/>
-  </p:clrMapOvr>
-</p:sld>
-</file>
-
-<file path=ppt/slides/slide3.xml><?xml version="1.0" encoding="utf-8"?>
-<p:sld xmlns:a="http://schemas.openxmlformats.org/drawingml/2006/main" xmlns:p="http://schemas.openxmlformats.org/presentationml/2006/main" xmlns:r="http://schemas.openxmlformats.org/officeDocument/2006/relationships">
-  <p:cSld>
-    <p:bg>
-      <p:bgPr>
-        <a:solidFill>
-          <a:srgbClr val="18181B"/>
-        </a:solidFill>
-        <a:effectLst/>
-      </p:bgPr>
-    </p:bg>
-    <p:spTree>
-      <p:nvGrpSpPr>
-        <p:cNvPr id="1" name=""/>
-        <p:cNvGrpSpPr/>
-        <p:nvPr/>
-      </p:nvGrpSpPr>
-      <p:grpSpPr/>
-      <p:sp>
-        <p:nvSpPr>
-          <p:cNvPr id="2" name="TextBox 1"/>
-          <p:cNvSpPr txBox="1"/>
-          <p:nvPr/>
-        </p:nvSpPr>
-        <p:spPr>
-          <a:xfrm>
-            <a:off x="731520" y="411480"/>
-            <a:ext cx="10698480" cy="1005840"/>
-          </a:xfrm>
-          <a:prstGeom prst="rect">
-            <a:avLst/>
-          </a:prstGeom>
-          <a:noFill/>
-        </p:spPr>
-        <p:txBody>
-          <a:bodyPr wrap="square">
-            <a:spAutoFit/>
-          </a:bodyPr>
-          <a:lstStyle/>
-          <a:p>
-            <a:pPr algn="l"/>
-            <a:r>
-              <a:rPr sz="2800" b="1">
-                <a:solidFill>
-                  <a:srgbClr val="FFFFFF"/>
-                </a:solidFill>
-              </a:rPr>
-              <a:t>The hook system</a:t>
-            </a:r>
-          </a:p>
-        </p:txBody>
-      </p:sp>
-      <p:sp>
-        <p:nvSpPr>
           <p:cNvPr id="3" name="Rectangle 2"/>
           <p:cNvSpPr/>
           <p:nvPr/>
         </p:nvSpPr>
         <p:spPr>
           <a:xfrm>
-            <a:off x="731520" y="1417320"/>
-            <a:ext cx="10698480" cy="36576"/>
+            <a:off x="0" y="0"/>
+            <a:ext cx="12191695" cy="54864"/>
           </a:xfrm>
           <a:prstGeom prst="rect">
             <a:avLst/>
           </a:prstGeom>
           <a:solidFill>
-            <a:srgbClr val="A1A1AA"/>
+            <a:srgbClr val="6366F1"/>
           </a:solidFill>
           <a:ln>
             <a:noFill/>
@@ -3554,8 +3188,8 @@
         </p:nvSpPr>
         <p:spPr>
           <a:xfrm>
-            <a:off x="731520" y="1600200"/>
-            <a:ext cx="10698480" cy="960120"/>
+            <a:off x="914400" y="1645920"/>
+            <a:ext cx="10332720" cy="457200"/>
           </a:xfrm>
           <a:prstGeom prst="rect">
             <a:avLst/>
@@ -3568,14 +3202,14 @@
           </a:bodyPr>
           <a:lstStyle/>
           <a:p>
-            <a:pPr algn="l"/>
-            <a:r>
-              <a:rPr sz="1700" b="0">
-                <a:solidFill>
-                  <a:srgbClr val="FFFFFF"/>
+            <a:pPr algn="ctr"/>
+            <a:r>
+              <a:rPr sz="1600" b="1">
+                <a:solidFill>
+                  <a:srgbClr val="A1A1AA"/>
                 </a:solidFill>
               </a:rPr>
-              <a:t>  Hooks are callback functions attached to the agent lifecycle. They run synchronously in your process before or after every tool call. The SD</a:t>
+              <a:t>CHAPTER 5</a:t>
             </a:r>
           </a:p>
         </p:txBody>
@@ -3588,8 +3222,8 @@
         </p:nvSpPr>
         <p:spPr>
           <a:xfrm>
-            <a:off x="731520" y="2651760"/>
-            <a:ext cx="10698480" cy="960120"/>
+            <a:off x="914400" y="2194560"/>
+            <a:ext cx="10332720" cy="1828800"/>
           </a:xfrm>
           <a:prstGeom prst="rect">
             <a:avLst/>
@@ -3602,14 +3236,15 @@
           </a:bodyPr>
           <a:lstStyle/>
           <a:p>
-            <a:pPr algn="l"/>
-            <a:r>
-              <a:rPr sz="1700" b="0">
+            <a:pPr algn="ctr"/>
+            <a:r>
+              <a:rPr sz="3600" b="1">
                 <a:solidFill>
                   <a:srgbClr val="FFFFFF"/>
                 </a:solidFill>
               </a:rPr>
-              <a:t>  from claude_agent_sdk import query, ClaudeAgentOptions, HookMatcher</a:t>
+              <a:t>Production: deploy + observability
++ cost controls</a:t>
             </a:r>
           </a:p>
         </p:txBody>
@@ -3622,8 +3257,8 @@
         </p:nvSpPr>
         <p:spPr>
           <a:xfrm>
-            <a:off x="731520" y="3703320"/>
-            <a:ext cx="10698480" cy="960120"/>
+            <a:off x="914400" y="4572000"/>
+            <a:ext cx="10332720" cy="457200"/>
           </a:xfrm>
           <a:prstGeom prst="rect">
             <a:avLst/>
@@ -3636,14 +3271,14 @@
           </a:bodyPr>
           <a:lstStyle/>
           <a:p>
-            <a:pPr algn="l"/>
-            <a:r>
-              <a:rPr sz="1700" b="0">
-                <a:solidFill>
-                  <a:srgbClr val="FFFFFF"/>
+            <a:pPr algn="ctr"/>
+            <a:r>
+              <a:rPr sz="1400" b="0">
+                <a:solidFill>
+                  <a:srgbClr val="A1A1AA"/>
                 </a:solidFill>
               </a:rPr>
-              <a:t>  async def my_hook(input_data: dict, tool_use_id: str, context: dict) -&gt; dict:</a:t>
+              <a:t>Production Agents: Claude Agent SDK + MCP Connector — Koenig AI Academy</a:t>
             </a:r>
           </a:p>
         </p:txBody>
@@ -3656,42 +3291,8 @@
         </p:nvSpPr>
         <p:spPr>
           <a:xfrm>
-            <a:off x="731520" y="4754880"/>
-            <a:ext cx="10698480" cy="960120"/>
-          </a:xfrm>
-          <a:prstGeom prst="rect">
-            <a:avLst/>
-          </a:prstGeom>
-          <a:noFill/>
-        </p:spPr>
-        <p:txBody>
-          <a:bodyPr wrap="square">
-            <a:spAutoFit/>
-          </a:bodyPr>
-          <a:lstStyle/>
-          <a:p>
-            <a:pPr algn="l"/>
-            <a:r>
-              <a:rPr sz="1700" b="0">
-                <a:solidFill>
-                  <a:srgbClr val="FFFFFF"/>
-                </a:solidFill>
-              </a:rPr>
-              <a:t>  # Return {} to pass through, or raise to block</a:t>
-            </a:r>
-          </a:p>
-        </p:txBody>
-      </p:sp>
-      <p:sp>
-        <p:nvSpPr>
-          <p:cNvPr id="8" name="TextBox 7"/>
-          <p:cNvSpPr txBox="1"/>
-          <p:nvPr/>
-        </p:nvSpPr>
-        <p:spPr>
-          <a:xfrm>
-            <a:off x="731520" y="6263640"/>
-            <a:ext cx="10698480" cy="365760"/>
+            <a:off x="457200" y="6492240"/>
+            <a:ext cx="11247120" cy="320040"/>
           </a:xfrm>
           <a:prstGeom prst="rect">
             <a:avLst/>
@@ -3724,17 +3325,9 @@
 </p:sld>
 </file>
 
-<file path=ppt/slides/slide4.xml><?xml version="1.0" encoding="utf-8"?>
+<file path=ppt/slides/slide2.xml><?xml version="1.0" encoding="utf-8"?>
 <p:sld xmlns:a="http://schemas.openxmlformats.org/drawingml/2006/main" xmlns:p="http://schemas.openxmlformats.org/presentationml/2006/main" xmlns:r="http://schemas.openxmlformats.org/officeDocument/2006/relationships">
   <p:cSld>
-    <p:bg>
-      <p:bgPr>
-        <a:solidFill>
-          <a:srgbClr val="18181B"/>
-        </a:solidFill>
-        <a:effectLst/>
-      </p:bgPr>
-    </p:bg>
     <p:spTree>
       <p:nvGrpSpPr>
         <p:cNvPr id="1" name=""/>
@@ -3744,54 +3337,20 @@
       <p:grpSpPr/>
       <p:sp>
         <p:nvSpPr>
-          <p:cNvPr id="2" name="TextBox 1"/>
-          <p:cNvSpPr txBox="1"/>
-          <p:nvPr/>
-        </p:nvSpPr>
-        <p:spPr>
-          <a:xfrm>
-            <a:off x="731520" y="411480"/>
-            <a:ext cx="10698480" cy="1005840"/>
-          </a:xfrm>
-          <a:prstGeom prst="rect">
-            <a:avLst/>
-          </a:prstGeom>
-          <a:noFill/>
-        </p:spPr>
-        <p:txBody>
-          <a:bodyPr wrap="square">
-            <a:spAutoFit/>
-          </a:bodyPr>
-          <a:lstStyle/>
-          <a:p>
-            <a:pPr algn="l"/>
-            <a:r>
-              <a:rPr sz="2800" b="1">
-                <a:solidFill>
-                  <a:srgbClr val="FFFFFF"/>
-                </a:solidFill>
-              </a:rPr>
-              <a:t>Hook 1: Audit log (PostToolUse)</a:t>
-            </a:r>
-          </a:p>
-        </p:txBody>
-      </p:sp>
-      <p:sp>
-        <p:nvSpPr>
-          <p:cNvPr id="3" name="Rectangle 2"/>
+          <p:cNvPr id="2" name="Rectangle 1"/>
           <p:cNvSpPr/>
           <p:nvPr/>
         </p:nvSpPr>
         <p:spPr>
           <a:xfrm>
-            <a:off x="731520" y="1417320"/>
-            <a:ext cx="10698480" cy="36576"/>
+            <a:off x="0" y="0"/>
+            <a:ext cx="12191695" cy="6858000"/>
           </a:xfrm>
           <a:prstGeom prst="rect">
             <a:avLst/>
           </a:prstGeom>
           <a:solidFill>
-            <a:srgbClr val="A1A1AA"/>
+            <a:srgbClr val="18181B"/>
           </a:solidFill>
           <a:ln>
             <a:noFill/>
@@ -3821,250 +3380,20 @@
       </p:sp>
       <p:sp>
         <p:nvSpPr>
-          <p:cNvPr id="4" name="TextBox 3"/>
-          <p:cNvSpPr txBox="1"/>
-          <p:nvPr/>
-        </p:nvSpPr>
-        <p:spPr>
-          <a:xfrm>
-            <a:off x="731520" y="1600200"/>
-            <a:ext cx="10698480" cy="960120"/>
-          </a:xfrm>
-          <a:prstGeom prst="rect">
-            <a:avLst/>
-          </a:prstGeom>
-          <a:noFill/>
-        </p:spPr>
-        <p:txBody>
-          <a:bodyPr wrap="square">
-            <a:spAutoFit/>
-          </a:bodyPr>
-          <a:lstStyle/>
-          <a:p>
-            <a:pPr algn="l"/>
-            <a:r>
-              <a:rPr sz="1700" b="0">
-                <a:solidFill>
-                  <a:srgbClr val="FFFFFF"/>
-                </a:solidFill>
-              </a:rPr>
-              <a:t>  Every file modification should be logged with a timestamp, file path, and session ID. This hook runs after every successful Edit or Write ca</a:t>
-            </a:r>
-          </a:p>
-        </p:txBody>
-      </p:sp>
-      <p:sp>
-        <p:nvSpPr>
-          <p:cNvPr id="5" name="TextBox 4"/>
-          <p:cNvSpPr txBox="1"/>
-          <p:nvPr/>
-        </p:nvSpPr>
-        <p:spPr>
-          <a:xfrm>
-            <a:off x="731520" y="2651760"/>
-            <a:ext cx="10698480" cy="960120"/>
-          </a:xfrm>
-          <a:prstGeom prst="rect">
-            <a:avLst/>
-          </a:prstGeom>
-          <a:noFill/>
-        </p:spPr>
-        <p:txBody>
-          <a:bodyPr wrap="square">
-            <a:spAutoFit/>
-          </a:bodyPr>
-          <a:lstStyle/>
-          <a:p>
-            <a:pPr algn="l"/>
-            <a:r>
-              <a:rPr sz="1700" b="0">
-                <a:solidFill>
-                  <a:srgbClr val="FFFFFF"/>
-                </a:solidFill>
-              </a:rPr>
-              <a:t>  from datetime import datetime</a:t>
-            </a:r>
-          </a:p>
-        </p:txBody>
-      </p:sp>
-      <p:sp>
-        <p:nvSpPr>
-          <p:cNvPr id="6" name="TextBox 5"/>
-          <p:cNvSpPr txBox="1"/>
-          <p:nvPr/>
-        </p:nvSpPr>
-        <p:spPr>
-          <a:xfrm>
-            <a:off x="731520" y="3703320"/>
-            <a:ext cx="10698480" cy="960120"/>
-          </a:xfrm>
-          <a:prstGeom prst="rect">
-            <a:avLst/>
-          </a:prstGeom>
-          <a:noFill/>
-        </p:spPr>
-        <p:txBody>
-          <a:bodyPr wrap="square">
-            <a:spAutoFit/>
-          </a:bodyPr>
-          <a:lstStyle/>
-          <a:p>
-            <a:pPr algn="l"/>
-            <a:r>
-              <a:rPr sz="1700" b="0">
-                <a:solidFill>
-                  <a:srgbClr val="FFFFFF"/>
-                </a:solidFill>
-              </a:rPr>
-              <a:t>  from claude_agent_sdk import query, ClaudeAgentOptions, HookMatcher</a:t>
-            </a:r>
-          </a:p>
-        </p:txBody>
-      </p:sp>
-      <p:sp>
-        <p:nvSpPr>
-          <p:cNvPr id="7" name="TextBox 6"/>
-          <p:cNvSpPr txBox="1"/>
-          <p:nvPr/>
-        </p:nvSpPr>
-        <p:spPr>
-          <a:xfrm>
-            <a:off x="731520" y="4754880"/>
-            <a:ext cx="10698480" cy="960120"/>
-          </a:xfrm>
-          <a:prstGeom prst="rect">
-            <a:avLst/>
-          </a:prstGeom>
-          <a:noFill/>
-        </p:spPr>
-        <p:txBody>
-          <a:bodyPr wrap="square">
-            <a:spAutoFit/>
-          </a:bodyPr>
-          <a:lstStyle/>
-          <a:p>
-            <a:pPr algn="l"/>
-            <a:r>
-              <a:rPr sz="1700" b="0">
-                <a:solidFill>
-                  <a:srgbClr val="FFFFFF"/>
-                </a:solidFill>
-              </a:rPr>
-              <a:t>  # Configure structured JSON logging</a:t>
-            </a:r>
-          </a:p>
-        </p:txBody>
-      </p:sp>
-      <p:sp>
-        <p:nvSpPr>
-          <p:cNvPr id="8" name="TextBox 7"/>
-          <p:cNvSpPr txBox="1"/>
-          <p:nvPr/>
-        </p:nvSpPr>
-        <p:spPr>
-          <a:xfrm>
-            <a:off x="731520" y="6263640"/>
-            <a:ext cx="10698480" cy="365760"/>
-          </a:xfrm>
-          <a:prstGeom prst="rect">
-            <a:avLst/>
-          </a:prstGeom>
-          <a:noFill/>
-        </p:spPr>
-        <p:txBody>
-          <a:bodyPr wrap="square">
-            <a:spAutoFit/>
-          </a:bodyPr>
-          <a:lstStyle/>
-          <a:p>
-            <a:pPr algn="l"/>
-            <a:r>
-              <a:rPr sz="1000" b="0">
-                <a:solidFill>
-                  <a:srgbClr val="A1A1AA"/>
-                </a:solidFill>
-              </a:rPr>
-              <a:t>academy.kspl.tech | Koenig AI Academy</a:t>
-            </a:r>
-          </a:p>
-        </p:txBody>
-      </p:sp>
-    </p:spTree>
-  </p:cSld>
-  <p:clrMapOvr>
-    <a:masterClrMapping/>
-  </p:clrMapOvr>
-</p:sld>
-</file>
-
-<file path=ppt/slides/slide5.xml><?xml version="1.0" encoding="utf-8"?>
-<p:sld xmlns:a="http://schemas.openxmlformats.org/drawingml/2006/main" xmlns:p="http://schemas.openxmlformats.org/presentationml/2006/main" xmlns:r="http://schemas.openxmlformats.org/officeDocument/2006/relationships">
-  <p:cSld>
-    <p:bg>
-      <p:bgPr>
-        <a:solidFill>
-          <a:srgbClr val="18181B"/>
-        </a:solidFill>
-        <a:effectLst/>
-      </p:bgPr>
-    </p:bg>
-    <p:spTree>
-      <p:nvGrpSpPr>
-        <p:cNvPr id="1" name=""/>
-        <p:cNvGrpSpPr/>
-        <p:nvPr/>
-      </p:nvGrpSpPr>
-      <p:grpSpPr/>
-      <p:sp>
-        <p:nvSpPr>
-          <p:cNvPr id="2" name="TextBox 1"/>
-          <p:cNvSpPr txBox="1"/>
-          <p:nvPr/>
-        </p:nvSpPr>
-        <p:spPr>
-          <a:xfrm>
-            <a:off x="731520" y="411480"/>
-            <a:ext cx="10698480" cy="1005840"/>
-          </a:xfrm>
-          <a:prstGeom prst="rect">
-            <a:avLst/>
-          </a:prstGeom>
-          <a:noFill/>
-        </p:spPr>
-        <p:txBody>
-          <a:bodyPr wrap="square">
-            <a:spAutoFit/>
-          </a:bodyPr>
-          <a:lstStyle/>
-          <a:p>
-            <a:pPr algn="l"/>
-            <a:r>
-              <a:rPr sz="2800" b="1">
-                <a:solidFill>
-                  <a:srgbClr val="FFFFFF"/>
-                </a:solidFill>
-              </a:rPr>
-              <a:t>Hook 2: Cost circuit breaker (Stop)</a:t>
-            </a:r>
-          </a:p>
-        </p:txBody>
-      </p:sp>
-      <p:sp>
-        <p:nvSpPr>
           <p:cNvPr id="3" name="Rectangle 2"/>
           <p:cNvSpPr/>
           <p:nvPr/>
         </p:nvSpPr>
         <p:spPr>
           <a:xfrm>
-            <a:off x="731520" y="1417320"/>
-            <a:ext cx="10698480" cy="36576"/>
+            <a:off x="0" y="0"/>
+            <a:ext cx="12191695" cy="54864"/>
           </a:xfrm>
           <a:prstGeom prst="rect">
             <a:avLst/>
           </a:prstGeom>
           <a:solidFill>
-            <a:srgbClr val="A1A1AA"/>
+            <a:srgbClr val="6366F1"/>
           </a:solidFill>
           <a:ln>
             <a:noFill/>
@@ -4100,8 +3429,8 @@
         </p:nvSpPr>
         <p:spPr>
           <a:xfrm>
-            <a:off x="731520" y="1600200"/>
-            <a:ext cx="10698480" cy="960120"/>
+            <a:off x="457200" y="164592"/>
+            <a:ext cx="11247120" cy="868680"/>
           </a:xfrm>
           <a:prstGeom prst="rect">
             <a:avLst/>
@@ -4116,222 +3445,26 @@
           <a:p>
             <a:pPr algn="l"/>
             <a:r>
-              <a:rPr sz="1700" b="0">
+              <a:rPr sz="2800" b="1">
                 <a:solidFill>
                   <a:srgbClr val="FFFFFF"/>
                 </a:solidFill>
               </a:rPr>
-              <a:t>  The Stop hook fires when the agent's stop_reason indicates it has finished — or when you want to force an early stop. Use PreToolUse with a </a:t>
-            </a:r>
-          </a:p>
-        </p:txBody>
-      </p:sp>
-      <p:sp>
-        <p:nvSpPr>
-          <p:cNvPr id="5" name="TextBox 4"/>
-          <p:cNvSpPr txBox="1"/>
-          <p:nvPr/>
-        </p:nvSpPr>
-        <p:spPr>
-          <a:xfrm>
-            <a:off x="731520" y="2651760"/>
-            <a:ext cx="10698480" cy="960120"/>
-          </a:xfrm>
-          <a:prstGeom prst="rect">
-            <a:avLst/>
-          </a:prstGeom>
-          <a:noFill/>
-        </p:spPr>
-        <p:txBody>
-          <a:bodyPr wrap="square">
-            <a:spAutoFit/>
-          </a:bodyPr>
-          <a:lstStyle/>
-          <a:p>
-            <a:pPr algn="l"/>
-            <a:r>
-              <a:rPr sz="1700" b="0">
-                <a:solidFill>
-                  <a:srgbClr val="FFFFFF"/>
-                </a:solidFill>
-              </a:rPr>
-              <a:t>  class CostCircuitBreaker:</a:t>
-            </a:r>
-          </a:p>
-        </p:txBody>
-      </p:sp>
-      <p:sp>
-        <p:nvSpPr>
-          <p:cNvPr id="6" name="TextBox 5"/>
-          <p:cNvSpPr txBox="1"/>
-          <p:nvPr/>
-        </p:nvSpPr>
-        <p:spPr>
-          <a:xfrm>
-            <a:off x="731520" y="3703320"/>
-            <a:ext cx="10698480" cy="960120"/>
-          </a:xfrm>
-          <a:prstGeom prst="rect">
-            <a:avLst/>
-          </a:prstGeom>
-          <a:noFill/>
-        </p:spPr>
-        <p:txBody>
-          <a:bodyPr wrap="square">
-            <a:spAutoFit/>
-          </a:bodyPr>
-          <a:lstStyle/>
-          <a:p>
-            <a:pPr algn="l"/>
-            <a:r>
-              <a:rPr sz="1700" b="0">
-                <a:solidFill>
-                  <a:srgbClr val="FFFFFF"/>
-                </a:solidFill>
-              </a:rPr>
-              <a:t>  """Track estimated token cost and abort if threshold is exceeded."""</a:t>
-            </a:r>
-          </a:p>
-        </p:txBody>
-      </p:sp>
-      <p:sp>
-        <p:nvSpPr>
-          <p:cNvPr id="7" name="TextBox 6"/>
-          <p:cNvSpPr txBox="1"/>
-          <p:nvPr/>
-        </p:nvSpPr>
-        <p:spPr>
-          <a:xfrm>
-            <a:off x="731520" y="4754880"/>
-            <a:ext cx="10698480" cy="960120"/>
-          </a:xfrm>
-          <a:prstGeom prst="rect">
-            <a:avLst/>
-          </a:prstGeom>
-          <a:noFill/>
-        </p:spPr>
-        <p:txBody>
-          <a:bodyPr wrap="square">
-            <a:spAutoFit/>
-          </a:bodyPr>
-          <a:lstStyle/>
-          <a:p>
-            <a:pPr algn="l"/>
-            <a:r>
-              <a:rPr sz="1700" b="0">
-                <a:solidFill>
-                  <a:srgbClr val="FFFFFF"/>
-                </a:solidFill>
-              </a:rPr>
-              <a:t>  def __init__(self, max_input_tokens: int = 500_000):</a:t>
-            </a:r>
-          </a:p>
-        </p:txBody>
-      </p:sp>
-      <p:sp>
-        <p:nvSpPr>
-          <p:cNvPr id="8" name="TextBox 7"/>
-          <p:cNvSpPr txBox="1"/>
-          <p:nvPr/>
-        </p:nvSpPr>
-        <p:spPr>
-          <a:xfrm>
-            <a:off x="731520" y="6263640"/>
-            <a:ext cx="10698480" cy="365760"/>
-          </a:xfrm>
-          <a:prstGeom prst="rect">
-            <a:avLst/>
-          </a:prstGeom>
-          <a:noFill/>
-        </p:spPr>
-        <p:txBody>
-          <a:bodyPr wrap="square">
-            <a:spAutoFit/>
-          </a:bodyPr>
-          <a:lstStyle/>
-          <a:p>
-            <a:pPr algn="l"/>
-            <a:r>
-              <a:rPr sz="1000" b="0">
-                <a:solidFill>
-                  <a:srgbClr val="A1A1AA"/>
-                </a:solidFill>
-              </a:rPr>
-              <a:t>academy.kspl.tech | Koenig AI Academy</a:t>
-            </a:r>
-          </a:p>
-        </p:txBody>
-      </p:sp>
-    </p:spTree>
-  </p:cSld>
-  <p:clrMapOvr>
-    <a:masterClrMapping/>
-  </p:clrMapOvr>
-</p:sld>
-</file>
-
-<file path=ppt/slides/slide6.xml><?xml version="1.0" encoding="utf-8"?>
-<p:sld xmlns:a="http://schemas.openxmlformats.org/drawingml/2006/main" xmlns:p="http://schemas.openxmlformats.org/presentationml/2006/main" xmlns:r="http://schemas.openxmlformats.org/officeDocument/2006/relationships">
-  <p:cSld>
-    <p:bg>
-      <p:bgPr>
-        <a:solidFill>
-          <a:srgbClr val="18181B"/>
-        </a:solidFill>
-        <a:effectLst/>
-      </p:bgPr>
-    </p:bg>
-    <p:spTree>
-      <p:nvGrpSpPr>
-        <p:cNvPr id="1" name=""/>
-        <p:cNvGrpSpPr/>
-        <p:nvPr/>
-      </p:nvGrpSpPr>
-      <p:grpSpPr/>
-      <p:sp>
-        <p:nvSpPr>
-          <p:cNvPr id="2" name="TextBox 1"/>
-          <p:cNvSpPr txBox="1"/>
-          <p:nvPr/>
-        </p:nvSpPr>
-        <p:spPr>
-          <a:xfrm>
-            <a:off x="731520" y="411480"/>
-            <a:ext cx="10698480" cy="1005840"/>
-          </a:xfrm>
-          <a:prstGeom prst="rect">
-            <a:avLst/>
-          </a:prstGeom>
-          <a:noFill/>
-        </p:spPr>
-        <p:txBody>
-          <a:bodyPr wrap="square">
-            <a:spAutoFit/>
-          </a:bodyPr>
-          <a:lstStyle/>
-          <a:p>
-            <a:pPr algn="l"/>
-            <a:r>
-              <a:rPr sz="2800" b="1">
-                <a:solidFill>
-                  <a:srgbClr val="FFFFFF"/>
-                </a:solidFill>
-              </a:rPr>
-              <a:t>Hook 3: Session initialization (SessionStart)</a:t>
-            </a:r>
-          </a:p>
-        </p:txBody>
-      </p:sp>
-      <p:sp>
-        <p:nvSpPr>
-          <p:cNvPr id="3" name="Rectangle 2"/>
+              <a:t>The Hook System — four callbacks, full lifecycle</a:t>
+            </a:r>
+          </a:p>
+        </p:txBody>
+      </p:sp>
+      <p:sp>
+        <p:nvSpPr>
+          <p:cNvPr id="5" name="Rectangle 4"/>
           <p:cNvSpPr/>
           <p:nvPr/>
         </p:nvSpPr>
         <p:spPr>
           <a:xfrm>
-            <a:off x="731520" y="1417320"/>
-            <a:ext cx="10698480" cy="36576"/>
+            <a:off x="457200" y="1143000"/>
+            <a:ext cx="11247120" cy="27432"/>
           </a:xfrm>
           <a:prstGeom prst="rect">
             <a:avLst/>
@@ -4367,14 +3500,14 @@
       </p:sp>
       <p:sp>
         <p:nvSpPr>
-          <p:cNvPr id="4" name="TextBox 3"/>
+          <p:cNvPr id="6" name="TextBox 5"/>
           <p:cNvSpPr txBox="1"/>
           <p:nvPr/>
         </p:nvSpPr>
         <p:spPr>
           <a:xfrm>
-            <a:off x="731520" y="1600200"/>
-            <a:ext cx="10698480" cy="960120"/>
+            <a:off x="502920" y="1298448"/>
+            <a:ext cx="11155680" cy="731520"/>
           </a:xfrm>
           <a:prstGeom prst="rect">
             <a:avLst/>
@@ -4389,26 +3522,26 @@
           <a:p>
             <a:pPr algn="l"/>
             <a:r>
-              <a:rPr sz="1700" b="0">
+              <a:rPr sz="1500" b="0">
                 <a:solidFill>
                   <a:srgbClr val="FFFFFF"/>
                 </a:solidFill>
               </a:rPr>
-              <a:t>  Use SessionStart to inject session metadata into your observability system as soon as the session opens:</a:t>
-            </a:r>
-          </a:p>
-        </p:txBody>
-      </p:sp>
-      <p:sp>
-        <p:nvSpPr>
-          <p:cNvPr id="5" name="TextBox 4"/>
+              <a:t>▸  Hooks are synchronous callbacks in ClaudeAgentOptions.hooks; HookMatcher filters by tool name regex</a:t>
+            </a:r>
+          </a:p>
+        </p:txBody>
+      </p:sp>
+      <p:sp>
+        <p:nvSpPr>
+          <p:cNvPr id="7" name="TextBox 6"/>
           <p:cNvSpPr txBox="1"/>
           <p:nvPr/>
         </p:nvSpPr>
         <p:spPr>
           <a:xfrm>
-            <a:off x="731520" y="2651760"/>
-            <a:ext cx="10698480" cy="960120"/>
+            <a:off x="502920" y="2121408"/>
+            <a:ext cx="11155680" cy="731520"/>
           </a:xfrm>
           <a:prstGeom prst="rect">
             <a:avLst/>
@@ -4423,26 +3556,26 @@
           <a:p>
             <a:pPr algn="l"/>
             <a:r>
-              <a:rPr sz="1700" b="0">
+              <a:rPr sz="1500" b="0">
                 <a:solidFill>
                   <a:srgbClr val="FFFFFF"/>
                 </a:solidFill>
               </a:rPr>
-              <a:t>  async def session_start(input_data: dict, tool_use_id: str, context: dict) -&gt; dict:</a:t>
-            </a:r>
-          </a:p>
-        </p:txBody>
-      </p:sp>
-      <p:sp>
-        <p:nvSpPr>
-          <p:cNvPr id="6" name="TextBox 5"/>
+              <a:t>▸  PreToolUse fires before execution — return permissionDecision: deny to block before any side effect</a:t>
+            </a:r>
+          </a:p>
+        </p:txBody>
+      </p:sp>
+      <p:sp>
+        <p:nvSpPr>
+          <p:cNvPr id="8" name="TextBox 7"/>
           <p:cNvSpPr txBox="1"/>
           <p:nvPr/>
         </p:nvSpPr>
         <p:spPr>
           <a:xfrm>
-            <a:off x="731520" y="3703320"/>
-            <a:ext cx="10698480" cy="960120"/>
+            <a:off x="502920" y="2944368"/>
+            <a:ext cx="11155680" cy="731520"/>
           </a:xfrm>
           <a:prstGeom prst="rect">
             <a:avLst/>
@@ -4457,26 +3590,26 @@
           <a:p>
             <a:pPr algn="l"/>
             <a:r>
-              <a:rPr sz="1700" b="0">
+              <a:rPr sz="1500" b="0">
                 <a:solidFill>
                   <a:srgbClr val="FFFFFF"/>
                 </a:solidFill>
               </a:rPr>
-              <a:t>  session_id = context.get("session_id", "unknown")</a:t>
-            </a:r>
-          </a:p>
-        </p:txBody>
-      </p:sp>
-      <p:sp>
-        <p:nvSpPr>
-          <p:cNvPr id="7" name="TextBox 6"/>
+              <a:t>▸  PostToolUse fires after execution — always returns {}; use for audit logging, not for blocking</a:t>
+            </a:r>
+          </a:p>
+        </p:txBody>
+      </p:sp>
+      <p:sp>
+        <p:nvSpPr>
+          <p:cNvPr id="9" name="TextBox 8"/>
           <p:cNvSpPr txBox="1"/>
           <p:nvPr/>
         </p:nvSpPr>
         <p:spPr>
           <a:xfrm>
-            <a:off x="731520" y="4754880"/>
-            <a:ext cx="10698480" cy="960120"/>
+            <a:off x="502920" y="3767328"/>
+            <a:ext cx="11155680" cy="731520"/>
           </a:xfrm>
           <a:prstGeom prst="rect">
             <a:avLst/>
@@ -4491,12 +3624,329 @@
           <a:p>
             <a:pPr algn="l"/>
             <a:r>
-              <a:rPr sz="1700" b="0">
+              <a:rPr sz="1500" b="0">
                 <a:solidFill>
                   <a:srgbClr val="FFFFFF"/>
                 </a:solidFill>
               </a:rPr>
-              <a:t>  # Emit a structured start event for Langfuse or your logging backend</a:t>
+              <a:t>▸  Python SDK supports tool, prompt, stop, compaction, permission, notification, subagent events</a:t>
+            </a:r>
+          </a:p>
+        </p:txBody>
+      </p:sp>
+      <p:sp>
+        <p:nvSpPr>
+          <p:cNvPr id="10" name="TextBox 9"/>
+          <p:cNvSpPr txBox="1"/>
+          <p:nvPr/>
+        </p:nvSpPr>
+        <p:spPr>
+          <a:xfrm>
+            <a:off x="502920" y="4590288"/>
+            <a:ext cx="11155680" cy="731520"/>
+          </a:xfrm>
+          <a:prstGeom prst="rect">
+            <a:avLst/>
+          </a:prstGeom>
+          <a:noFill/>
+        </p:spPr>
+        <p:txBody>
+          <a:bodyPr wrap="square">
+            <a:spAutoFit/>
+          </a:bodyPr>
+          <a:lstStyle/>
+          <a:p>
+            <a:pPr algn="l"/>
+            <a:r>
+              <a:rPr sz="1500" b="0">
+                <a:solidFill>
+                  <a:srgbClr val="FFFFFF"/>
+                </a:solidFill>
+              </a:rPr>
+              <a:t>▸  Python lacks SessionStart/SessionEnd — those lifecycle events are TypeScript-SDK only</a:t>
+            </a:r>
+          </a:p>
+        </p:txBody>
+      </p:sp>
+      <p:sp>
+        <p:nvSpPr>
+          <p:cNvPr id="11" name="TextBox 10"/>
+          <p:cNvSpPr txBox="1"/>
+          <p:nvPr/>
+        </p:nvSpPr>
+        <p:spPr>
+          <a:xfrm>
+            <a:off x="457200" y="6492240"/>
+            <a:ext cx="11247120" cy="320040"/>
+          </a:xfrm>
+          <a:prstGeom prst="rect">
+            <a:avLst/>
+          </a:prstGeom>
+          <a:noFill/>
+        </p:spPr>
+        <p:txBody>
+          <a:bodyPr wrap="square">
+            <a:spAutoFit/>
+          </a:bodyPr>
+          <a:lstStyle/>
+          <a:p>
+            <a:pPr algn="l"/>
+            <a:r>
+              <a:rPr sz="1000" b="0">
+                <a:solidFill>
+                  <a:srgbClr val="A1A1AA"/>
+                </a:solidFill>
+              </a:rPr>
+              <a:t>academy.kspl.tech | Koenig AI Academy</a:t>
+            </a:r>
+          </a:p>
+        </p:txBody>
+      </p:sp>
+    </p:spTree>
+  </p:cSld>
+  <p:clrMapOvr>
+    <a:masterClrMapping/>
+  </p:clrMapOvr>
+</p:sld>
+</file>
+
+<file path=ppt/slides/slide3.xml><?xml version="1.0" encoding="utf-8"?>
+<p:sld xmlns:a="http://schemas.openxmlformats.org/drawingml/2006/main" xmlns:p="http://schemas.openxmlformats.org/presentationml/2006/main" xmlns:r="http://schemas.openxmlformats.org/officeDocument/2006/relationships">
+  <p:cSld>
+    <p:spTree>
+      <p:nvGrpSpPr>
+        <p:cNvPr id="1" name=""/>
+        <p:cNvGrpSpPr/>
+        <p:nvPr/>
+      </p:nvGrpSpPr>
+      <p:grpSpPr/>
+      <p:sp>
+        <p:nvSpPr>
+          <p:cNvPr id="2" name="Rectangle 1"/>
+          <p:cNvSpPr/>
+          <p:nvPr/>
+        </p:nvSpPr>
+        <p:spPr>
+          <a:xfrm>
+            <a:off x="0" y="0"/>
+            <a:ext cx="12191695" cy="6858000"/>
+          </a:xfrm>
+          <a:prstGeom prst="rect">
+            <a:avLst/>
+          </a:prstGeom>
+          <a:solidFill>
+            <a:srgbClr val="18181B"/>
+          </a:solidFill>
+          <a:ln>
+            <a:noFill/>
+          </a:ln>
+        </p:spPr>
+        <p:style>
+          <a:lnRef idx="1">
+            <a:schemeClr val="accent1"/>
+          </a:lnRef>
+          <a:fillRef idx="3">
+            <a:schemeClr val="accent1"/>
+          </a:fillRef>
+          <a:effectRef idx="2">
+            <a:schemeClr val="accent1"/>
+          </a:effectRef>
+          <a:fontRef idx="minor">
+            <a:schemeClr val="lt1"/>
+          </a:fontRef>
+        </p:style>
+        <p:txBody>
+          <a:bodyPr rtlCol="0" anchor="ctr"/>
+          <a:lstStyle/>
+          <a:p>
+            <a:pPr algn="ctr"/>
+          </a:p>
+        </p:txBody>
+      </p:sp>
+      <p:sp>
+        <p:nvSpPr>
+          <p:cNvPr id="3" name="Rectangle 2"/>
+          <p:cNvSpPr/>
+          <p:nvPr/>
+        </p:nvSpPr>
+        <p:spPr>
+          <a:xfrm>
+            <a:off x="0" y="0"/>
+            <a:ext cx="12191695" cy="54864"/>
+          </a:xfrm>
+          <a:prstGeom prst="rect">
+            <a:avLst/>
+          </a:prstGeom>
+          <a:solidFill>
+            <a:srgbClr val="6366F1"/>
+          </a:solidFill>
+          <a:ln>
+            <a:noFill/>
+          </a:ln>
+        </p:spPr>
+        <p:style>
+          <a:lnRef idx="1">
+            <a:schemeClr val="accent1"/>
+          </a:lnRef>
+          <a:fillRef idx="3">
+            <a:schemeClr val="accent1"/>
+          </a:fillRef>
+          <a:effectRef idx="2">
+            <a:schemeClr val="accent1"/>
+          </a:effectRef>
+          <a:fontRef idx="minor">
+            <a:schemeClr val="lt1"/>
+          </a:fontRef>
+        </p:style>
+        <p:txBody>
+          <a:bodyPr rtlCol="0" anchor="ctr"/>
+          <a:lstStyle/>
+          <a:p>
+            <a:pPr algn="ctr"/>
+          </a:p>
+        </p:txBody>
+      </p:sp>
+      <p:sp>
+        <p:nvSpPr>
+          <p:cNvPr id="4" name="TextBox 3"/>
+          <p:cNvSpPr txBox="1"/>
+          <p:nvPr/>
+        </p:nvSpPr>
+        <p:spPr>
+          <a:xfrm>
+            <a:off x="457200" y="164592"/>
+            <a:ext cx="11247120" cy="868680"/>
+          </a:xfrm>
+          <a:prstGeom prst="rect">
+            <a:avLst/>
+          </a:prstGeom>
+          <a:noFill/>
+        </p:spPr>
+        <p:txBody>
+          <a:bodyPr wrap="square">
+            <a:spAutoFit/>
+          </a:bodyPr>
+          <a:lstStyle/>
+          <a:p>
+            <a:pPr algn="l"/>
+            <a:r>
+              <a:rPr sz="2800" b="1">
+                <a:solidFill>
+                  <a:srgbClr val="FFFFFF"/>
+                </a:solidFill>
+              </a:rPr>
+              <a:t>Hook 1 — Audit Log (PostToolUse)</a:t>
+            </a:r>
+          </a:p>
+        </p:txBody>
+      </p:sp>
+      <p:sp>
+        <p:nvSpPr>
+          <p:cNvPr id="5" name="Rectangle 4"/>
+          <p:cNvSpPr/>
+          <p:nvPr/>
+        </p:nvSpPr>
+        <p:spPr>
+          <a:xfrm>
+            <a:off x="457200" y="1143000"/>
+            <a:ext cx="11247120" cy="27432"/>
+          </a:xfrm>
+          <a:prstGeom prst="rect">
+            <a:avLst/>
+          </a:prstGeom>
+          <a:solidFill>
+            <a:srgbClr val="A1A1AA"/>
+          </a:solidFill>
+          <a:ln>
+            <a:noFill/>
+          </a:ln>
+        </p:spPr>
+        <p:style>
+          <a:lnRef idx="1">
+            <a:schemeClr val="accent1"/>
+          </a:lnRef>
+          <a:fillRef idx="3">
+            <a:schemeClr val="accent1"/>
+          </a:fillRef>
+          <a:effectRef idx="2">
+            <a:schemeClr val="accent1"/>
+          </a:effectRef>
+          <a:fontRef idx="minor">
+            <a:schemeClr val="lt1"/>
+          </a:fontRef>
+        </p:style>
+        <p:txBody>
+          <a:bodyPr rtlCol="0" anchor="ctr"/>
+          <a:lstStyle/>
+          <a:p>
+            <a:pPr algn="ctr"/>
+          </a:p>
+        </p:txBody>
+      </p:sp>
+      <p:sp>
+        <p:nvSpPr>
+          <p:cNvPr id="6" name="TextBox 5"/>
+          <p:cNvSpPr txBox="1"/>
+          <p:nvPr/>
+        </p:nvSpPr>
+        <p:spPr>
+          <a:xfrm>
+            <a:off x="502920" y="1298448"/>
+            <a:ext cx="11155680" cy="731520"/>
+          </a:xfrm>
+          <a:prstGeom prst="rect">
+            <a:avLst/>
+          </a:prstGeom>
+          <a:noFill/>
+        </p:spPr>
+        <p:txBody>
+          <a:bodyPr wrap="square">
+            <a:spAutoFit/>
+          </a:bodyPr>
+          <a:lstStyle/>
+          <a:p>
+            <a:pPr algn="l"/>
+            <a:r>
+              <a:rPr sz="1500" b="0">
+                <a:solidFill>
+                  <a:srgbClr val="FFFFFF"/>
+                </a:solidFill>
+              </a:rPr>
+              <a:t>▸  PostToolUse fires after every matched tool call, receiving tool_name, file_path, and session_id</a:t>
+            </a:r>
+          </a:p>
+        </p:txBody>
+      </p:sp>
+      <p:sp>
+        <p:nvSpPr>
+          <p:cNvPr id="7" name="TextBox 6"/>
+          <p:cNvSpPr txBox="1"/>
+          <p:nvPr/>
+        </p:nvSpPr>
+        <p:spPr>
+          <a:xfrm>
+            <a:off x="502920" y="2121408"/>
+            <a:ext cx="11155680" cy="731520"/>
+          </a:xfrm>
+          <a:prstGeom prst="rect">
+            <a:avLst/>
+          </a:prstGeom>
+          <a:noFill/>
+        </p:spPr>
+        <p:txBody>
+          <a:bodyPr wrap="square">
+            <a:spAutoFit/>
+          </a:bodyPr>
+          <a:lstStyle/>
+          <a:p>
+            <a:pPr algn="l"/>
+            <a:r>
+              <a:rPr sz="1500" b="0">
+                <a:solidFill>
+                  <a:srgbClr val="FFFFFF"/>
+                </a:solidFill>
+              </a:rPr>
+              <a:t>▸  Always return {} to pass through — PostToolUse cannot block a write that has already executed</a:t>
             </a:r>
           </a:p>
         </p:txBody>
@@ -4509,8 +3959,1265 @@
         </p:nvSpPr>
         <p:spPr>
           <a:xfrm>
-            <a:off x="731520" y="6263640"/>
-            <a:ext cx="10698480" cy="365760"/>
+            <a:off x="502920" y="2944368"/>
+            <a:ext cx="11155680" cy="731520"/>
+          </a:xfrm>
+          <a:prstGeom prst="rect">
+            <a:avLst/>
+          </a:prstGeom>
+          <a:noFill/>
+        </p:spPr>
+        <p:txBody>
+          <a:bodyPr wrap="square">
+            <a:spAutoFit/>
+          </a:bodyPr>
+          <a:lstStyle/>
+          <a:p>
+            <a:pPr algn="l"/>
+            <a:r>
+              <a:rPr sz="1500" b="0">
+                <a:solidFill>
+                  <a:srgbClr val="FFFFFF"/>
+                </a:solidFill>
+              </a:rPr>
+              <a:t>▸  When NOT to use: cost circuit breakers — the file is already written when PostToolUse fires</a:t>
+            </a:r>
+          </a:p>
+        </p:txBody>
+      </p:sp>
+      <p:sp>
+        <p:nvSpPr>
+          <p:cNvPr id="9" name="TextBox 8"/>
+          <p:cNvSpPr txBox="1"/>
+          <p:nvPr/>
+        </p:nvSpPr>
+        <p:spPr>
+          <a:xfrm>
+            <a:off x="502920" y="3767328"/>
+            <a:ext cx="11155680" cy="731520"/>
+          </a:xfrm>
+          <a:prstGeom prst="rect">
+            <a:avLst/>
+          </a:prstGeom>
+          <a:noFill/>
+        </p:spPr>
+        <p:txBody>
+          <a:bodyPr wrap="square">
+            <a:spAutoFit/>
+          </a:bodyPr>
+          <a:lstStyle/>
+          <a:p>
+            <a:pPr algn="l"/>
+            <a:r>
+              <a:rPr sz="1500" b="0">
+                <a:solidFill>
+                  <a:srgbClr val="FFFFFF"/>
+                </a:solidFill>
+              </a:rPr>
+              <a:t>▸  Log structured JSON, not print() — structured logs enable per-session queries and error rate dashboards</a:t>
+            </a:r>
+          </a:p>
+        </p:txBody>
+      </p:sp>
+      <p:sp>
+        <p:nvSpPr>
+          <p:cNvPr id="10" name="TextBox 9"/>
+          <p:cNvSpPr txBox="1"/>
+          <p:nvPr/>
+        </p:nvSpPr>
+        <p:spPr>
+          <a:xfrm>
+            <a:off x="502920" y="4590288"/>
+            <a:ext cx="11155680" cy="731520"/>
+          </a:xfrm>
+          <a:prstGeom prst="rect">
+            <a:avLst/>
+          </a:prstGeom>
+          <a:noFill/>
+        </p:spPr>
+        <p:txBody>
+          <a:bodyPr wrap="square">
+            <a:spAutoFit/>
+          </a:bodyPr>
+          <a:lstStyle/>
+          <a:p>
+            <a:pPr algn="l"/>
+            <a:r>
+              <a:rPr sz="1500" b="0">
+                <a:solidFill>
+                  <a:srgbClr val="FFFFFF"/>
+                </a:solidFill>
+              </a:rPr>
+              <a:t>▸  Footgun: if your logger raises an exception, wrap it in try/except or audit entries are silently lost</a:t>
+            </a:r>
+          </a:p>
+        </p:txBody>
+      </p:sp>
+      <p:sp>
+        <p:nvSpPr>
+          <p:cNvPr id="11" name="TextBox 10"/>
+          <p:cNvSpPr txBox="1"/>
+          <p:nvPr/>
+        </p:nvSpPr>
+        <p:spPr>
+          <a:xfrm>
+            <a:off x="457200" y="6492240"/>
+            <a:ext cx="11247120" cy="320040"/>
+          </a:xfrm>
+          <a:prstGeom prst="rect">
+            <a:avLst/>
+          </a:prstGeom>
+          <a:noFill/>
+        </p:spPr>
+        <p:txBody>
+          <a:bodyPr wrap="square">
+            <a:spAutoFit/>
+          </a:bodyPr>
+          <a:lstStyle/>
+          <a:p>
+            <a:pPr algn="l"/>
+            <a:r>
+              <a:rPr sz="1000" b="0">
+                <a:solidFill>
+                  <a:srgbClr val="A1A1AA"/>
+                </a:solidFill>
+              </a:rPr>
+              <a:t>academy.kspl.tech | Koenig AI Academy</a:t>
+            </a:r>
+          </a:p>
+        </p:txBody>
+      </p:sp>
+    </p:spTree>
+  </p:cSld>
+  <p:clrMapOvr>
+    <a:masterClrMapping/>
+  </p:clrMapOvr>
+</p:sld>
+</file>
+
+<file path=ppt/slides/slide4.xml><?xml version="1.0" encoding="utf-8"?>
+<p:sld xmlns:a="http://schemas.openxmlformats.org/drawingml/2006/main" xmlns:p="http://schemas.openxmlformats.org/presentationml/2006/main" xmlns:r="http://schemas.openxmlformats.org/officeDocument/2006/relationships">
+  <p:cSld>
+    <p:spTree>
+      <p:nvGrpSpPr>
+        <p:cNvPr id="1" name=""/>
+        <p:cNvGrpSpPr/>
+        <p:nvPr/>
+      </p:nvGrpSpPr>
+      <p:grpSpPr/>
+      <p:sp>
+        <p:nvSpPr>
+          <p:cNvPr id="2" name="Rectangle 1"/>
+          <p:cNvSpPr/>
+          <p:nvPr/>
+        </p:nvSpPr>
+        <p:spPr>
+          <a:xfrm>
+            <a:off x="0" y="0"/>
+            <a:ext cx="12191695" cy="6858000"/>
+          </a:xfrm>
+          <a:prstGeom prst="rect">
+            <a:avLst/>
+          </a:prstGeom>
+          <a:solidFill>
+            <a:srgbClr val="18181B"/>
+          </a:solidFill>
+          <a:ln>
+            <a:noFill/>
+          </a:ln>
+        </p:spPr>
+        <p:style>
+          <a:lnRef idx="1">
+            <a:schemeClr val="accent1"/>
+          </a:lnRef>
+          <a:fillRef idx="3">
+            <a:schemeClr val="accent1"/>
+          </a:fillRef>
+          <a:effectRef idx="2">
+            <a:schemeClr val="accent1"/>
+          </a:effectRef>
+          <a:fontRef idx="minor">
+            <a:schemeClr val="lt1"/>
+          </a:fontRef>
+        </p:style>
+        <p:txBody>
+          <a:bodyPr rtlCol="0" anchor="ctr"/>
+          <a:lstStyle/>
+          <a:p>
+            <a:pPr algn="ctr"/>
+          </a:p>
+        </p:txBody>
+      </p:sp>
+      <p:sp>
+        <p:nvSpPr>
+          <p:cNvPr id="3" name="Rectangle 2"/>
+          <p:cNvSpPr/>
+          <p:nvPr/>
+        </p:nvSpPr>
+        <p:spPr>
+          <a:xfrm>
+            <a:off x="0" y="0"/>
+            <a:ext cx="12191695" cy="54864"/>
+          </a:xfrm>
+          <a:prstGeom prst="rect">
+            <a:avLst/>
+          </a:prstGeom>
+          <a:solidFill>
+            <a:srgbClr val="6366F1"/>
+          </a:solidFill>
+          <a:ln>
+            <a:noFill/>
+          </a:ln>
+        </p:spPr>
+        <p:style>
+          <a:lnRef idx="1">
+            <a:schemeClr val="accent1"/>
+          </a:lnRef>
+          <a:fillRef idx="3">
+            <a:schemeClr val="accent1"/>
+          </a:fillRef>
+          <a:effectRef idx="2">
+            <a:schemeClr val="accent1"/>
+          </a:effectRef>
+          <a:fontRef idx="minor">
+            <a:schemeClr val="lt1"/>
+          </a:fontRef>
+        </p:style>
+        <p:txBody>
+          <a:bodyPr rtlCol="0" anchor="ctr"/>
+          <a:lstStyle/>
+          <a:p>
+            <a:pPr algn="ctr"/>
+          </a:p>
+        </p:txBody>
+      </p:sp>
+      <p:sp>
+        <p:nvSpPr>
+          <p:cNvPr id="4" name="TextBox 3"/>
+          <p:cNvSpPr txBox="1"/>
+          <p:nvPr/>
+        </p:nvSpPr>
+        <p:spPr>
+          <a:xfrm>
+            <a:off x="457200" y="164592"/>
+            <a:ext cx="11247120" cy="868680"/>
+          </a:xfrm>
+          <a:prstGeom prst="rect">
+            <a:avLst/>
+          </a:prstGeom>
+          <a:noFill/>
+        </p:spPr>
+        <p:txBody>
+          <a:bodyPr wrap="square">
+            <a:spAutoFit/>
+          </a:bodyPr>
+          <a:lstStyle/>
+          <a:p>
+            <a:pPr algn="l"/>
+            <a:r>
+              <a:rPr sz="2800" b="1">
+                <a:solidFill>
+                  <a:srgbClr val="FFFFFF"/>
+                </a:solidFill>
+              </a:rPr>
+              <a:t>Hook 2 — Cost Circuit Breaker (PreToolUse)</a:t>
+            </a:r>
+          </a:p>
+        </p:txBody>
+      </p:sp>
+      <p:sp>
+        <p:nvSpPr>
+          <p:cNvPr id="5" name="Rectangle 4"/>
+          <p:cNvSpPr/>
+          <p:nvPr/>
+        </p:nvSpPr>
+        <p:spPr>
+          <a:xfrm>
+            <a:off x="457200" y="1143000"/>
+            <a:ext cx="11247120" cy="27432"/>
+          </a:xfrm>
+          <a:prstGeom prst="rect">
+            <a:avLst/>
+          </a:prstGeom>
+          <a:solidFill>
+            <a:srgbClr val="A1A1AA"/>
+          </a:solidFill>
+          <a:ln>
+            <a:noFill/>
+          </a:ln>
+        </p:spPr>
+        <p:style>
+          <a:lnRef idx="1">
+            <a:schemeClr val="accent1"/>
+          </a:lnRef>
+          <a:fillRef idx="3">
+            <a:schemeClr val="accent1"/>
+          </a:fillRef>
+          <a:effectRef idx="2">
+            <a:schemeClr val="accent1"/>
+          </a:effectRef>
+          <a:fontRef idx="minor">
+            <a:schemeClr val="lt1"/>
+          </a:fontRef>
+        </p:style>
+        <p:txBody>
+          <a:bodyPr rtlCol="0" anchor="ctr"/>
+          <a:lstStyle/>
+          <a:p>
+            <a:pPr algn="ctr"/>
+          </a:p>
+        </p:txBody>
+      </p:sp>
+      <p:sp>
+        <p:nvSpPr>
+          <p:cNvPr id="6" name="TextBox 5"/>
+          <p:cNvSpPr txBox="1"/>
+          <p:nvPr/>
+        </p:nvSpPr>
+        <p:spPr>
+          <a:xfrm>
+            <a:off x="502920" y="1298448"/>
+            <a:ext cx="11155680" cy="731520"/>
+          </a:xfrm>
+          <a:prstGeom prst="rect">
+            <a:avLst/>
+          </a:prstGeom>
+          <a:noFill/>
+        </p:spPr>
+        <p:txBody>
+          <a:bodyPr wrap="square">
+            <a:spAutoFit/>
+          </a:bodyPr>
+          <a:lstStyle/>
+          <a:p>
+            <a:pPr algn="l"/>
+            <a:r>
+              <a:rPr sz="1500" b="0">
+                <a:solidFill>
+                  <a:srgbClr val="FFFFFF"/>
+                </a:solidFill>
+              </a:rPr>
+              <a:t>▸  PreToolUse fires before the tool executes — return permissionDecision: deny to block before side effects</a:t>
+            </a:r>
+          </a:p>
+        </p:txBody>
+      </p:sp>
+      <p:sp>
+        <p:nvSpPr>
+          <p:cNvPr id="7" name="TextBox 6"/>
+          <p:cNvSpPr txBox="1"/>
+          <p:nvPr/>
+        </p:nvSpPr>
+        <p:spPr>
+          <a:xfrm>
+            <a:off x="502920" y="2121408"/>
+            <a:ext cx="11155680" cy="731520"/>
+          </a:xfrm>
+          <a:prstGeom prst="rect">
+            <a:avLst/>
+          </a:prstGeom>
+          <a:noFill/>
+        </p:spPr>
+        <p:txBody>
+          <a:bodyPr wrap="square">
+            <a:spAutoFit/>
+          </a:bodyPr>
+          <a:lstStyle/>
+          <a:p>
+            <a:pPr algn="l"/>
+            <a:r>
+              <a:rPr sz="1500" b="0">
+                <a:solidFill>
+                  <a:srgbClr val="FFFFFF"/>
+                </a:solidFill>
+              </a:rPr>
+              <a:t>▸  Return {} to allow; return hookSpecificOutput with permissionDecision and a reason string to deny</a:t>
+            </a:r>
+          </a:p>
+        </p:txBody>
+      </p:sp>
+      <p:sp>
+        <p:nvSpPr>
+          <p:cNvPr id="8" name="TextBox 7"/>
+          <p:cNvSpPr txBox="1"/>
+          <p:nvPr/>
+        </p:nvSpPr>
+        <p:spPr>
+          <a:xfrm>
+            <a:off x="502920" y="2944368"/>
+            <a:ext cx="11155680" cy="731520"/>
+          </a:xfrm>
+          <a:prstGeom prst="rect">
+            <a:avLst/>
+          </a:prstGeom>
+          <a:noFill/>
+        </p:spPr>
+        <p:txBody>
+          <a:bodyPr wrap="square">
+            <a:spAutoFit/>
+          </a:bodyPr>
+          <a:lstStyle/>
+          <a:p>
+            <a:pPr algn="l"/>
+            <a:r>
+              <a:rPr sz="1500" b="0">
+                <a:solidFill>
+                  <a:srgbClr val="FFFFFF"/>
+                </a:solidFill>
+              </a:rPr>
+              <a:t>▸  Track cumulative input tokens in a class instance; trip the breaker when usage exceeds the cap</a:t>
+            </a:r>
+          </a:p>
+        </p:txBody>
+      </p:sp>
+      <p:sp>
+        <p:nvSpPr>
+          <p:cNvPr id="9" name="TextBox 8"/>
+          <p:cNvSpPr txBox="1"/>
+          <p:nvPr/>
+        </p:nvSpPr>
+        <p:spPr>
+          <a:xfrm>
+            <a:off x="502920" y="3767328"/>
+            <a:ext cx="11155680" cy="731520"/>
+          </a:xfrm>
+          <a:prstGeom prst="rect">
+            <a:avLst/>
+          </a:prstGeom>
+          <a:noFill/>
+        </p:spPr>
+        <p:txBody>
+          <a:bodyPr wrap="square">
+            <a:spAutoFit/>
+          </a:bodyPr>
+          <a:lstStyle/>
+          <a:p>
+            <a:pPr algn="l"/>
+            <a:r>
+              <a:rPr sz="1500" b="0">
+                <a:solidFill>
+                  <a:srgbClr val="FFFFFF"/>
+                </a:solidFill>
+              </a:rPr>
+              <a:t>▸  Production gotcha: never block silently — always include a reason so Claude gets actionable feedback</a:t>
+            </a:r>
+          </a:p>
+        </p:txBody>
+      </p:sp>
+      <p:sp>
+        <p:nvSpPr>
+          <p:cNvPr id="10" name="TextBox 9"/>
+          <p:cNvSpPr txBox="1"/>
+          <p:nvPr/>
+        </p:nvSpPr>
+        <p:spPr>
+          <a:xfrm>
+            <a:off x="502920" y="4590288"/>
+            <a:ext cx="11155680" cy="731520"/>
+          </a:xfrm>
+          <a:prstGeom prst="rect">
+            <a:avLst/>
+          </a:prstGeom>
+          <a:noFill/>
+        </p:spPr>
+        <p:txBody>
+          <a:bodyPr wrap="square">
+            <a:spAutoFit/>
+          </a:bodyPr>
+          <a:lstStyle/>
+          <a:p>
+            <a:pPr algn="l"/>
+            <a:r>
+              <a:rPr sz="1500" b="0">
+                <a:solidFill>
+                  <a:srgbClr val="FFFFFF"/>
+                </a:solidFill>
+              </a:rPr>
+              <a:t>▸  Sonnet 5 migration: rebaseline your token cap — Sonnet 5 generates ~30% more tokens per equivalent prompt</a:t>
+            </a:r>
+          </a:p>
+        </p:txBody>
+      </p:sp>
+      <p:sp>
+        <p:nvSpPr>
+          <p:cNvPr id="11" name="TextBox 10"/>
+          <p:cNvSpPr txBox="1"/>
+          <p:nvPr/>
+        </p:nvSpPr>
+        <p:spPr>
+          <a:xfrm>
+            <a:off x="457200" y="6492240"/>
+            <a:ext cx="11247120" cy="320040"/>
+          </a:xfrm>
+          <a:prstGeom prst="rect">
+            <a:avLst/>
+          </a:prstGeom>
+          <a:noFill/>
+        </p:spPr>
+        <p:txBody>
+          <a:bodyPr wrap="square">
+            <a:spAutoFit/>
+          </a:bodyPr>
+          <a:lstStyle/>
+          <a:p>
+            <a:pPr algn="l"/>
+            <a:r>
+              <a:rPr sz="1000" b="0">
+                <a:solidFill>
+                  <a:srgbClr val="A1A1AA"/>
+                </a:solidFill>
+              </a:rPr>
+              <a:t>academy.kspl.tech | Koenig AI Academy</a:t>
+            </a:r>
+          </a:p>
+        </p:txBody>
+      </p:sp>
+    </p:spTree>
+  </p:cSld>
+  <p:clrMapOvr>
+    <a:masterClrMapping/>
+  </p:clrMapOvr>
+</p:sld>
+</file>
+
+<file path=ppt/slides/slide5.xml><?xml version="1.0" encoding="utf-8"?>
+<p:sld xmlns:a="http://schemas.openxmlformats.org/drawingml/2006/main" xmlns:p="http://schemas.openxmlformats.org/presentationml/2006/main" xmlns:r="http://schemas.openxmlformats.org/officeDocument/2006/relationships">
+  <p:cSld>
+    <p:spTree>
+      <p:nvGrpSpPr>
+        <p:cNvPr id="1" name=""/>
+        <p:cNvGrpSpPr/>
+        <p:nvPr/>
+      </p:nvGrpSpPr>
+      <p:grpSpPr/>
+      <p:sp>
+        <p:nvSpPr>
+          <p:cNvPr id="2" name="Rectangle 1"/>
+          <p:cNvSpPr/>
+          <p:nvPr/>
+        </p:nvSpPr>
+        <p:spPr>
+          <a:xfrm>
+            <a:off x="0" y="0"/>
+            <a:ext cx="12191695" cy="6858000"/>
+          </a:xfrm>
+          <a:prstGeom prst="rect">
+            <a:avLst/>
+          </a:prstGeom>
+          <a:solidFill>
+            <a:srgbClr val="18181B"/>
+          </a:solidFill>
+          <a:ln>
+            <a:noFill/>
+          </a:ln>
+        </p:spPr>
+        <p:style>
+          <a:lnRef idx="1">
+            <a:schemeClr val="accent1"/>
+          </a:lnRef>
+          <a:fillRef idx="3">
+            <a:schemeClr val="accent1"/>
+          </a:fillRef>
+          <a:effectRef idx="2">
+            <a:schemeClr val="accent1"/>
+          </a:effectRef>
+          <a:fontRef idx="minor">
+            <a:schemeClr val="lt1"/>
+          </a:fontRef>
+        </p:style>
+        <p:txBody>
+          <a:bodyPr rtlCol="0" anchor="ctr"/>
+          <a:lstStyle/>
+          <a:p>
+            <a:pPr algn="ctr"/>
+          </a:p>
+        </p:txBody>
+      </p:sp>
+      <p:sp>
+        <p:nvSpPr>
+          <p:cNvPr id="3" name="Rectangle 2"/>
+          <p:cNvSpPr/>
+          <p:nvPr/>
+        </p:nvSpPr>
+        <p:spPr>
+          <a:xfrm>
+            <a:off x="0" y="0"/>
+            <a:ext cx="12191695" cy="54864"/>
+          </a:xfrm>
+          <a:prstGeom prst="rect">
+            <a:avLst/>
+          </a:prstGeom>
+          <a:solidFill>
+            <a:srgbClr val="6366F1"/>
+          </a:solidFill>
+          <a:ln>
+            <a:noFill/>
+          </a:ln>
+        </p:spPr>
+        <p:style>
+          <a:lnRef idx="1">
+            <a:schemeClr val="accent1"/>
+          </a:lnRef>
+          <a:fillRef idx="3">
+            <a:schemeClr val="accent1"/>
+          </a:fillRef>
+          <a:effectRef idx="2">
+            <a:schemeClr val="accent1"/>
+          </a:effectRef>
+          <a:fontRef idx="minor">
+            <a:schemeClr val="lt1"/>
+          </a:fontRef>
+        </p:style>
+        <p:txBody>
+          <a:bodyPr rtlCol="0" anchor="ctr"/>
+          <a:lstStyle/>
+          <a:p>
+            <a:pPr algn="ctr"/>
+          </a:p>
+        </p:txBody>
+      </p:sp>
+      <p:sp>
+        <p:nvSpPr>
+          <p:cNvPr id="4" name="TextBox 3"/>
+          <p:cNvSpPr txBox="1"/>
+          <p:nvPr/>
+        </p:nvSpPr>
+        <p:spPr>
+          <a:xfrm>
+            <a:off x="457200" y="164592"/>
+            <a:ext cx="11247120" cy="868680"/>
+          </a:xfrm>
+          <a:prstGeom prst="rect">
+            <a:avLst/>
+          </a:prstGeom>
+          <a:noFill/>
+        </p:spPr>
+        <p:txBody>
+          <a:bodyPr wrap="square">
+            <a:spAutoFit/>
+          </a:bodyPr>
+          <a:lstStyle/>
+          <a:p>
+            <a:pPr algn="l"/>
+            <a:r>
+              <a:rPr sz="2800" b="1">
+                <a:solidFill>
+                  <a:srgbClr val="FFFFFF"/>
+                </a:solidFill>
+              </a:rPr>
+              <a:t>Hook 3 — Session Lifecycle Telemetry</a:t>
+            </a:r>
+          </a:p>
+        </p:txBody>
+      </p:sp>
+      <p:sp>
+        <p:nvSpPr>
+          <p:cNvPr id="5" name="Rectangle 4"/>
+          <p:cNvSpPr/>
+          <p:nvPr/>
+        </p:nvSpPr>
+        <p:spPr>
+          <a:xfrm>
+            <a:off x="457200" y="1143000"/>
+            <a:ext cx="11247120" cy="27432"/>
+          </a:xfrm>
+          <a:prstGeom prst="rect">
+            <a:avLst/>
+          </a:prstGeom>
+          <a:solidFill>
+            <a:srgbClr val="A1A1AA"/>
+          </a:solidFill>
+          <a:ln>
+            <a:noFill/>
+          </a:ln>
+        </p:spPr>
+        <p:style>
+          <a:lnRef idx="1">
+            <a:schemeClr val="accent1"/>
+          </a:lnRef>
+          <a:fillRef idx="3">
+            <a:schemeClr val="accent1"/>
+          </a:fillRef>
+          <a:effectRef idx="2">
+            <a:schemeClr val="accent1"/>
+          </a:effectRef>
+          <a:fontRef idx="minor">
+            <a:schemeClr val="lt1"/>
+          </a:fontRef>
+        </p:style>
+        <p:txBody>
+          <a:bodyPr rtlCol="0" anchor="ctr"/>
+          <a:lstStyle/>
+          <a:p>
+            <a:pPr algn="ctr"/>
+          </a:p>
+        </p:txBody>
+      </p:sp>
+      <p:sp>
+        <p:nvSpPr>
+          <p:cNvPr id="6" name="TextBox 5"/>
+          <p:cNvSpPr txBox="1"/>
+          <p:nvPr/>
+        </p:nvSpPr>
+        <p:spPr>
+          <a:xfrm>
+            <a:off x="502920" y="1298448"/>
+            <a:ext cx="11155680" cy="731520"/>
+          </a:xfrm>
+          <a:prstGeom prst="rect">
+            <a:avLst/>
+          </a:prstGeom>
+          <a:noFill/>
+        </p:spPr>
+        <p:txBody>
+          <a:bodyPr wrap="square">
+            <a:spAutoFit/>
+          </a:bodyPr>
+          <a:lstStyle/>
+          <a:p>
+            <a:pPr algn="l"/>
+            <a:r>
+              <a:rPr sz="1500" b="0">
+                <a:solidFill>
+                  <a:srgbClr val="FFFFFF"/>
+                </a:solidFill>
+              </a:rPr>
+              <a:t>▸  Python SDK has no SessionStart or SessionEnd events — emit session-start from the first message instead</a:t>
+            </a:r>
+          </a:p>
+        </p:txBody>
+      </p:sp>
+      <p:sp>
+        <p:nvSpPr>
+          <p:cNvPr id="7" name="TextBox 6"/>
+          <p:cNvSpPr txBox="1"/>
+          <p:nvPr/>
+        </p:nvSpPr>
+        <p:spPr>
+          <a:xfrm>
+            <a:off x="502920" y="2121408"/>
+            <a:ext cx="11155680" cy="731520"/>
+          </a:xfrm>
+          <a:prstGeom prst="rect">
+            <a:avLst/>
+          </a:prstGeom>
+          <a:noFill/>
+        </p:spPr>
+        <p:txBody>
+          <a:bodyPr wrap="square">
+            <a:spAutoFit/>
+          </a:bodyPr>
+          <a:lstStyle/>
+          <a:p>
+            <a:pPr algn="l"/>
+            <a:r>
+              <a:rPr sz="1500" b="0">
+                <a:solidFill>
+                  <a:srgbClr val="FFFFFF"/>
+                </a:solidFill>
+              </a:rPr>
+              <a:t>▸  TypeScript SDK: register hooks.SessionStart with an async callback that fires before any tool call</a:t>
+            </a:r>
+          </a:p>
+        </p:txBody>
+      </p:sp>
+      <p:sp>
+        <p:nvSpPr>
+          <p:cNvPr id="8" name="TextBox 7"/>
+          <p:cNvSpPr txBox="1"/>
+          <p:nvPr/>
+        </p:nvSpPr>
+        <p:spPr>
+          <a:xfrm>
+            <a:off x="502920" y="2944368"/>
+            <a:ext cx="11155680" cy="731520"/>
+          </a:xfrm>
+          <a:prstGeom prst="rect">
+            <a:avLst/>
+          </a:prstGeom>
+          <a:noFill/>
+        </p:spPr>
+        <p:txBody>
+          <a:bodyPr wrap="square">
+            <a:spAutoFit/>
+          </a:bodyPr>
+          <a:lstStyle/>
+          <a:p>
+            <a:pPr algn="l"/>
+            <a:r>
+              <a:rPr sz="1500" b="0">
+                <a:solidFill>
+                  <a:srgbClr val="FFFFFF"/>
+                </a:solidFill>
+              </a:rPr>
+              <a:t>▸  The SessionStart hook receives session_id, cwd, and environment context in the input dict</a:t>
+            </a:r>
+          </a:p>
+        </p:txBody>
+      </p:sp>
+      <p:sp>
+        <p:nvSpPr>
+          <p:cNvPr id="9" name="TextBox 8"/>
+          <p:cNvSpPr txBox="1"/>
+          <p:nvPr/>
+        </p:nvSpPr>
+        <p:spPr>
+          <a:xfrm>
+            <a:off x="502920" y="3767328"/>
+            <a:ext cx="11155680" cy="731520"/>
+          </a:xfrm>
+          <a:prstGeom prst="rect">
+            <a:avLst/>
+          </a:prstGeom>
+          <a:noFill/>
+        </p:spPr>
+        <p:txBody>
+          <a:bodyPr wrap="square">
+            <a:spAutoFit/>
+          </a:bodyPr>
+          <a:lstStyle/>
+          <a:p>
+            <a:pPr algn="l"/>
+            <a:r>
+              <a:rPr sz="1500" b="0">
+                <a:solidFill>
+                  <a:srgbClr val="FFFFFF"/>
+                </a:solidFill>
+              </a:rPr>
+              <a:t>▸  Python workaround: log from the first SystemMessage to capture session_id before tool calls begin</a:t>
+            </a:r>
+          </a:p>
+        </p:txBody>
+      </p:sp>
+      <p:sp>
+        <p:nvSpPr>
+          <p:cNvPr id="10" name="TextBox 9"/>
+          <p:cNvSpPr txBox="1"/>
+          <p:nvPr/>
+        </p:nvSpPr>
+        <p:spPr>
+          <a:xfrm>
+            <a:off x="502920" y="4590288"/>
+            <a:ext cx="11155680" cy="731520"/>
+          </a:xfrm>
+          <a:prstGeom prst="rect">
+            <a:avLst/>
+          </a:prstGeom>
+          <a:noFill/>
+        </p:spPr>
+        <p:txBody>
+          <a:bodyPr wrap="square">
+            <a:spAutoFit/>
+          </a:bodyPr>
+          <a:lstStyle/>
+          <a:p>
+            <a:pPr algn="l"/>
+            <a:r>
+              <a:rPr sz="1500" b="0">
+                <a:solidFill>
+                  <a:srgbClr val="FFFFFF"/>
+                </a:solidFill>
+              </a:rPr>
+              <a:t>▸  When NOT to use TypeScript sessions in Python: the callback is simply not invoked; no error is raised</a:t>
+            </a:r>
+          </a:p>
+        </p:txBody>
+      </p:sp>
+      <p:sp>
+        <p:nvSpPr>
+          <p:cNvPr id="11" name="TextBox 10"/>
+          <p:cNvSpPr txBox="1"/>
+          <p:nvPr/>
+        </p:nvSpPr>
+        <p:spPr>
+          <a:xfrm>
+            <a:off x="457200" y="6492240"/>
+            <a:ext cx="11247120" cy="320040"/>
+          </a:xfrm>
+          <a:prstGeom prst="rect">
+            <a:avLst/>
+          </a:prstGeom>
+          <a:noFill/>
+        </p:spPr>
+        <p:txBody>
+          <a:bodyPr wrap="square">
+            <a:spAutoFit/>
+          </a:bodyPr>
+          <a:lstStyle/>
+          <a:p>
+            <a:pPr algn="l"/>
+            <a:r>
+              <a:rPr sz="1000" b="0">
+                <a:solidFill>
+                  <a:srgbClr val="A1A1AA"/>
+                </a:solidFill>
+              </a:rPr>
+              <a:t>academy.kspl.tech | Koenig AI Academy</a:t>
+            </a:r>
+          </a:p>
+        </p:txBody>
+      </p:sp>
+    </p:spTree>
+  </p:cSld>
+  <p:clrMapOvr>
+    <a:masterClrMapping/>
+  </p:clrMapOvr>
+</p:sld>
+</file>
+
+<file path=ppt/slides/slide6.xml><?xml version="1.0" encoding="utf-8"?>
+<p:sld xmlns:a="http://schemas.openxmlformats.org/drawingml/2006/main" xmlns:p="http://schemas.openxmlformats.org/presentationml/2006/main" xmlns:r="http://schemas.openxmlformats.org/officeDocument/2006/relationships">
+  <p:cSld>
+    <p:spTree>
+      <p:nvGrpSpPr>
+        <p:cNvPr id="1" name=""/>
+        <p:cNvGrpSpPr/>
+        <p:nvPr/>
+      </p:nvGrpSpPr>
+      <p:grpSpPr/>
+      <p:sp>
+        <p:nvSpPr>
+          <p:cNvPr id="2" name="Rectangle 1"/>
+          <p:cNvSpPr/>
+          <p:nvPr/>
+        </p:nvSpPr>
+        <p:spPr>
+          <a:xfrm>
+            <a:off x="0" y="0"/>
+            <a:ext cx="12191695" cy="6858000"/>
+          </a:xfrm>
+          <a:prstGeom prst="rect">
+            <a:avLst/>
+          </a:prstGeom>
+          <a:solidFill>
+            <a:srgbClr val="18181B"/>
+          </a:solidFill>
+          <a:ln>
+            <a:noFill/>
+          </a:ln>
+        </p:spPr>
+        <p:style>
+          <a:lnRef idx="1">
+            <a:schemeClr val="accent1"/>
+          </a:lnRef>
+          <a:fillRef idx="3">
+            <a:schemeClr val="accent1"/>
+          </a:fillRef>
+          <a:effectRef idx="2">
+            <a:schemeClr val="accent1"/>
+          </a:effectRef>
+          <a:fontRef idx="minor">
+            <a:schemeClr val="lt1"/>
+          </a:fontRef>
+        </p:style>
+        <p:txBody>
+          <a:bodyPr rtlCol="0" anchor="ctr"/>
+          <a:lstStyle/>
+          <a:p>
+            <a:pPr algn="ctr"/>
+          </a:p>
+        </p:txBody>
+      </p:sp>
+      <p:sp>
+        <p:nvSpPr>
+          <p:cNvPr id="3" name="Rectangle 2"/>
+          <p:cNvSpPr/>
+          <p:nvPr/>
+        </p:nvSpPr>
+        <p:spPr>
+          <a:xfrm>
+            <a:off x="0" y="0"/>
+            <a:ext cx="12191695" cy="54864"/>
+          </a:xfrm>
+          <a:prstGeom prst="rect">
+            <a:avLst/>
+          </a:prstGeom>
+          <a:solidFill>
+            <a:srgbClr val="6366F1"/>
+          </a:solidFill>
+          <a:ln>
+            <a:noFill/>
+          </a:ln>
+        </p:spPr>
+        <p:style>
+          <a:lnRef idx="1">
+            <a:schemeClr val="accent1"/>
+          </a:lnRef>
+          <a:fillRef idx="3">
+            <a:schemeClr val="accent1"/>
+          </a:fillRef>
+          <a:effectRef idx="2">
+            <a:schemeClr val="accent1"/>
+          </a:effectRef>
+          <a:fontRef idx="minor">
+            <a:schemeClr val="lt1"/>
+          </a:fontRef>
+        </p:style>
+        <p:txBody>
+          <a:bodyPr rtlCol="0" anchor="ctr"/>
+          <a:lstStyle/>
+          <a:p>
+            <a:pPr algn="ctr"/>
+          </a:p>
+        </p:txBody>
+      </p:sp>
+      <p:sp>
+        <p:nvSpPr>
+          <p:cNvPr id="4" name="TextBox 3"/>
+          <p:cNvSpPr txBox="1"/>
+          <p:nvPr/>
+        </p:nvSpPr>
+        <p:spPr>
+          <a:xfrm>
+            <a:off x="457200" y="164592"/>
+            <a:ext cx="11247120" cy="868680"/>
+          </a:xfrm>
+          <a:prstGeom prst="rect">
+            <a:avLst/>
+          </a:prstGeom>
+          <a:noFill/>
+        </p:spPr>
+        <p:txBody>
+          <a:bodyPr wrap="square">
+            <a:spAutoFit/>
+          </a:bodyPr>
+          <a:lstStyle/>
+          <a:p>
+            <a:pPr algn="l"/>
+            <a:r>
+              <a:rPr sz="2800" b="1">
+                <a:solidFill>
+                  <a:srgbClr val="FFFFFF"/>
+                </a:solidFill>
+              </a:rPr>
+              <a:t>Hook 4 — Prompt Sanitization (UserPromptSubmit)</a:t>
+            </a:r>
+          </a:p>
+        </p:txBody>
+      </p:sp>
+      <p:sp>
+        <p:nvSpPr>
+          <p:cNvPr id="5" name="Rectangle 4"/>
+          <p:cNvSpPr/>
+          <p:nvPr/>
+        </p:nvSpPr>
+        <p:spPr>
+          <a:xfrm>
+            <a:off x="457200" y="1143000"/>
+            <a:ext cx="11247120" cy="27432"/>
+          </a:xfrm>
+          <a:prstGeom prst="rect">
+            <a:avLst/>
+          </a:prstGeom>
+          <a:solidFill>
+            <a:srgbClr val="A1A1AA"/>
+          </a:solidFill>
+          <a:ln>
+            <a:noFill/>
+          </a:ln>
+        </p:spPr>
+        <p:style>
+          <a:lnRef idx="1">
+            <a:schemeClr val="accent1"/>
+          </a:lnRef>
+          <a:fillRef idx="3">
+            <a:schemeClr val="accent1"/>
+          </a:fillRef>
+          <a:effectRef idx="2">
+            <a:schemeClr val="accent1"/>
+          </a:effectRef>
+          <a:fontRef idx="minor">
+            <a:schemeClr val="lt1"/>
+          </a:fontRef>
+        </p:style>
+        <p:txBody>
+          <a:bodyPr rtlCol="0" anchor="ctr"/>
+          <a:lstStyle/>
+          <a:p>
+            <a:pPr algn="ctr"/>
+          </a:p>
+        </p:txBody>
+      </p:sp>
+      <p:sp>
+        <p:nvSpPr>
+          <p:cNvPr id="6" name="TextBox 5"/>
+          <p:cNvSpPr txBox="1"/>
+          <p:nvPr/>
+        </p:nvSpPr>
+        <p:spPr>
+          <a:xfrm>
+            <a:off x="502920" y="1298448"/>
+            <a:ext cx="11155680" cy="731520"/>
+          </a:xfrm>
+          <a:prstGeom prst="rect">
+            <a:avLst/>
+          </a:prstGeom>
+          <a:noFill/>
+        </p:spPr>
+        <p:txBody>
+          <a:bodyPr wrap="square">
+            <a:spAutoFit/>
+          </a:bodyPr>
+          <a:lstStyle/>
+          <a:p>
+            <a:pPr algn="l"/>
+            <a:r>
+              <a:rPr sz="1500" b="0">
+                <a:solidFill>
+                  <a:srgbClr val="FFFFFF"/>
+                </a:solidFill>
+              </a:rPr>
+              <a:t>▸  UserPromptSubmit fires before the prompt reaches the model — strip PII at this point, not in PostToolUse</a:t>
+            </a:r>
+          </a:p>
+        </p:txBody>
+      </p:sp>
+      <p:sp>
+        <p:nvSpPr>
+          <p:cNvPr id="7" name="TextBox 6"/>
+          <p:cNvSpPr txBox="1"/>
+          <p:nvPr/>
+        </p:nvSpPr>
+        <p:spPr>
+          <a:xfrm>
+            <a:off x="502920" y="2121408"/>
+            <a:ext cx="11155680" cy="731520"/>
+          </a:xfrm>
+          <a:prstGeom prst="rect">
+            <a:avLst/>
+          </a:prstGeom>
+          <a:noFill/>
+        </p:spPr>
+        <p:txBody>
+          <a:bodyPr wrap="square">
+            <a:spAutoFit/>
+          </a:bodyPr>
+          <a:lstStyle/>
+          <a:p>
+            <a:pPr algn="l"/>
+            <a:r>
+              <a:rPr sz="1500" b="0">
+                <a:solidFill>
+                  <a:srgbClr val="FFFFFF"/>
+                </a:solidFill>
+              </a:rPr>
+              <a:t>▸  Return a modified input_data dict with the cleaned prompt to replace the original message in the pipeline</a:t>
+            </a:r>
+          </a:p>
+        </p:txBody>
+      </p:sp>
+      <p:sp>
+        <p:nvSpPr>
+          <p:cNvPr id="8" name="TextBox 7"/>
+          <p:cNvSpPr txBox="1"/>
+          <p:nvPr/>
+        </p:nvSpPr>
+        <p:spPr>
+          <a:xfrm>
+            <a:off x="502920" y="2944368"/>
+            <a:ext cx="11155680" cy="731520"/>
+          </a:xfrm>
+          <a:prstGeom prst="rect">
+            <a:avLst/>
+          </a:prstGeom>
+          <a:noFill/>
+        </p:spPr>
+        <p:txBody>
+          <a:bodyPr wrap="square">
+            <a:spAutoFit/>
+          </a:bodyPr>
+          <a:lstStyle/>
+          <a:p>
+            <a:pPr algn="l"/>
+            <a:r>
+              <a:rPr sz="1500" b="0">
+                <a:solidFill>
+                  <a:srgbClr val="FFFFFF"/>
+                </a:solidFill>
+              </a:rPr>
+              <a:t>▸  When to use: PII redaction, profanity filters, prompt-injection detection, context injection</a:t>
+            </a:r>
+          </a:p>
+        </p:txBody>
+      </p:sp>
+      <p:sp>
+        <p:nvSpPr>
+          <p:cNvPr id="9" name="TextBox 8"/>
+          <p:cNvSpPr txBox="1"/>
+          <p:nvPr/>
+        </p:nvSpPr>
+        <p:spPr>
+          <a:xfrm>
+            <a:off x="502920" y="3767328"/>
+            <a:ext cx="11155680" cy="731520"/>
+          </a:xfrm>
+          <a:prstGeom prst="rect">
+            <a:avLst/>
+          </a:prstGeom>
+          <a:noFill/>
+        </p:spPr>
+        <p:txBody>
+          <a:bodyPr wrap="square">
+            <a:spAutoFit/>
+          </a:bodyPr>
+          <a:lstStyle/>
+          <a:p>
+            <a:pPr algn="l"/>
+            <a:r>
+              <a:rPr sz="1500" b="0">
+                <a:solidFill>
+                  <a:srgbClr val="FFFFFF"/>
+                </a:solidFill>
+              </a:rPr>
+              <a:t>▸  When NOT to use: tool result cleanup — use PostToolUse for that; this hook only sees the initial prompt</a:t>
+            </a:r>
+          </a:p>
+        </p:txBody>
+      </p:sp>
+      <p:sp>
+        <p:nvSpPr>
+          <p:cNvPr id="10" name="TextBox 9"/>
+          <p:cNvSpPr txBox="1"/>
+          <p:nvPr/>
+        </p:nvSpPr>
+        <p:spPr>
+          <a:xfrm>
+            <a:off x="502920" y="4590288"/>
+            <a:ext cx="11155680" cy="731520"/>
+          </a:xfrm>
+          <a:prstGeom prst="rect">
+            <a:avLst/>
+          </a:prstGeom>
+          <a:noFill/>
+        </p:spPr>
+        <p:txBody>
+          <a:bodyPr wrap="square">
+            <a:spAutoFit/>
+          </a:bodyPr>
+          <a:lstStyle/>
+          <a:p>
+            <a:pPr algn="l"/>
+            <a:r>
+              <a:rPr sz="1500" b="0">
+                <a:solidFill>
+                  <a:srgbClr val="FFFFFF"/>
+                </a:solidFill>
+              </a:rPr>
+              <a:t>▸  Footgun: always log when redaction occurs with session_id and pattern found — silent redaction fails audits</a:t>
+            </a:r>
+          </a:p>
+        </p:txBody>
+      </p:sp>
+      <p:sp>
+        <p:nvSpPr>
+          <p:cNvPr id="11" name="TextBox 10"/>
+          <p:cNvSpPr txBox="1"/>
+          <p:nvPr/>
+        </p:nvSpPr>
+        <p:spPr>
+          <a:xfrm>
+            <a:off x="457200" y="6492240"/>
+            <a:ext cx="11247120" cy="320040"/>
           </a:xfrm>
           <a:prstGeom prst="rect">
             <a:avLst/>
@@ -4546,14 +5253,6 @@
 <file path=ppt/slides/slide7.xml><?xml version="1.0" encoding="utf-8"?>
 <p:sld xmlns:a="http://schemas.openxmlformats.org/drawingml/2006/main" xmlns:p="http://schemas.openxmlformats.org/presentationml/2006/main" xmlns:r="http://schemas.openxmlformats.org/officeDocument/2006/relationships">
   <p:cSld>
-    <p:bg>
-      <p:bgPr>
-        <a:solidFill>
-          <a:srgbClr val="18181B"/>
-        </a:solidFill>
-        <a:effectLst/>
-      </p:bgPr>
-    </p:bg>
     <p:spTree>
       <p:nvGrpSpPr>
         <p:cNvPr id="1" name=""/>
@@ -4563,14 +5262,100 @@
       <p:grpSpPr/>
       <p:sp>
         <p:nvSpPr>
-          <p:cNvPr id="2" name="TextBox 1"/>
+          <p:cNvPr id="2" name="Rectangle 1"/>
+          <p:cNvSpPr/>
+          <p:nvPr/>
+        </p:nvSpPr>
+        <p:spPr>
+          <a:xfrm>
+            <a:off x="0" y="0"/>
+            <a:ext cx="12191695" cy="6858000"/>
+          </a:xfrm>
+          <a:prstGeom prst="rect">
+            <a:avLst/>
+          </a:prstGeom>
+          <a:solidFill>
+            <a:srgbClr val="18181B"/>
+          </a:solidFill>
+          <a:ln>
+            <a:noFill/>
+          </a:ln>
+        </p:spPr>
+        <p:style>
+          <a:lnRef idx="1">
+            <a:schemeClr val="accent1"/>
+          </a:lnRef>
+          <a:fillRef idx="3">
+            <a:schemeClr val="accent1"/>
+          </a:fillRef>
+          <a:effectRef idx="2">
+            <a:schemeClr val="accent1"/>
+          </a:effectRef>
+          <a:fontRef idx="minor">
+            <a:schemeClr val="lt1"/>
+          </a:fontRef>
+        </p:style>
+        <p:txBody>
+          <a:bodyPr rtlCol="0" anchor="ctr"/>
+          <a:lstStyle/>
+          <a:p>
+            <a:pPr algn="ctr"/>
+          </a:p>
+        </p:txBody>
+      </p:sp>
+      <p:sp>
+        <p:nvSpPr>
+          <p:cNvPr id="3" name="Rectangle 2"/>
+          <p:cNvSpPr/>
+          <p:nvPr/>
+        </p:nvSpPr>
+        <p:spPr>
+          <a:xfrm>
+            <a:off x="0" y="0"/>
+            <a:ext cx="54864" cy="6858000"/>
+          </a:xfrm>
+          <a:prstGeom prst="rect">
+            <a:avLst/>
+          </a:prstGeom>
+          <a:solidFill>
+            <a:srgbClr val="6366F1"/>
+          </a:solidFill>
+          <a:ln>
+            <a:noFill/>
+          </a:ln>
+        </p:spPr>
+        <p:style>
+          <a:lnRef idx="1">
+            <a:schemeClr val="accent1"/>
+          </a:lnRef>
+          <a:fillRef idx="3">
+            <a:schemeClr val="accent1"/>
+          </a:fillRef>
+          <a:effectRef idx="2">
+            <a:schemeClr val="accent1"/>
+          </a:effectRef>
+          <a:fontRef idx="minor">
+            <a:schemeClr val="lt1"/>
+          </a:fontRef>
+        </p:style>
+        <p:txBody>
+          <a:bodyPr rtlCol="0" anchor="ctr"/>
+          <a:lstStyle/>
+          <a:p>
+            <a:pPr algn="ctr"/>
+          </a:p>
+        </p:txBody>
+      </p:sp>
+      <p:sp>
+        <p:nvSpPr>
+          <p:cNvPr id="4" name="TextBox 3"/>
           <p:cNvSpPr txBox="1"/>
           <p:nvPr/>
         </p:nvSpPr>
         <p:spPr>
           <a:xfrm>
-            <a:off x="914400" y="2011680"/>
-            <a:ext cx="10332720" cy="914400"/>
+            <a:off x="914400" y="1828800"/>
+            <a:ext cx="10332720" cy="731520"/>
           </a:xfrm>
           <a:prstGeom prst="rect">
             <a:avLst/>
@@ -4585,26 +5370,26 @@
           <a:p>
             <a:pPr algn="ctr"/>
             <a:r>
-              <a:rPr sz="3400" b="1">
+              <a:rPr sz="3600" b="1">
                 <a:solidFill>
                   <a:srgbClr val="FFFFFF"/>
                 </a:solidFill>
               </a:rPr>
-              <a:t>Try it next</a:t>
-            </a:r>
-          </a:p>
-        </p:txBody>
-      </p:sp>
-      <p:sp>
-        <p:nvSpPr>
-          <p:cNvPr id="3" name="TextBox 2"/>
+              <a:t>Try It Next</a:t>
+            </a:r>
+          </a:p>
+        </p:txBody>
+      </p:sp>
+      <p:sp>
+        <p:nvSpPr>
+          <p:cNvPr id="5" name="TextBox 4"/>
           <p:cNvSpPr txBox="1"/>
           <p:nvPr/>
         </p:nvSpPr>
         <p:spPr>
           <a:xfrm>
-            <a:off x="914400" y="3200400"/>
-            <a:ext cx="10332720" cy="1097280"/>
+            <a:off x="914400" y="2743200"/>
+            <a:ext cx="10332720" cy="640080"/>
           </a:xfrm>
           <a:prstGeom prst="rect">
             <a:avLst/>
@@ -4624,21 +5409,21 @@
                   <a:srgbClr val="A1A1AA"/>
                 </a:solidFill>
               </a:rPr>
-              <a:t>Deploy a gateway with RBAC, rate limits, and JSONL auditing</a:t>
-            </a:r>
-          </a:p>
-        </p:txBody>
-      </p:sp>
-      <p:sp>
-        <p:nvSpPr>
-          <p:cNvPr id="4" name="TextBox 3"/>
+              <a:t>Add the production hook stack to an agent — verify the circuit breaker fires at a low token cap</a:t>
+            </a:r>
+          </a:p>
+        </p:txBody>
+      </p:sp>
+      <p:sp>
+        <p:nvSpPr>
+          <p:cNvPr id="6" name="TextBox 5"/>
           <p:cNvSpPr txBox="1"/>
           <p:nvPr/>
         </p:nvSpPr>
         <p:spPr>
           <a:xfrm>
-            <a:off x="731520" y="6263640"/>
-            <a:ext cx="10698480" cy="365760"/>
+            <a:off x="914400" y="3840480"/>
+            <a:ext cx="10332720" cy="457200"/>
           </a:xfrm>
           <a:prstGeom prst="rect">
             <a:avLst/>
@@ -4651,11 +5436,11 @@
           </a:bodyPr>
           <a:lstStyle/>
           <a:p>
-            <a:pPr algn="l"/>
-            <a:r>
-              <a:rPr sz="1000" b="0">
-                <a:solidFill>
-                  <a:srgbClr val="A1A1AA"/>
+            <a:pPr algn="ctr"/>
+            <a:r>
+              <a:rPr sz="1600" b="0">
+                <a:solidFill>
+                  <a:srgbClr val="6366F1"/>
                 </a:solidFill>
               </a:rPr>
               <a:t>academy.kspl.tech | Koenig AI Academy</a:t>

</xml_diff>